<commit_message>
Update PPTX to match simplified AI workflow instructions
Slide 8 Step 02 and Slide 12 Step 2 now say to point the AI agent at
AI_PROJECT_CREATION_INSTRUCTIONS.md, replacing the verbose list of files
to read manually.

Co-Authored-By: Claude Sonnet 4.6 <noreply@anthropic.com>
</commit_message>
<xml_diff>
--- a/Interpretable_Context_Methodology_(ICM).pptx
+++ b/Interpretable_Context_Methodology_(ICM).pptx
@@ -1849,7 +1849,7 @@
       </p:grpSpPr>
       <p:pic>
         <p:nvPicPr>
-          <p:cNvPr id="2" name="Image 0" descr="preencoded.png">    </p:cNvPr>
+          <p:cNvPr id="2" name="Image 0" descr="preencoded.png"/>
           <p:cNvPicPr>
             <a:picLocks noChangeAspect="1"/>
           </p:cNvPicPr>
@@ -2073,7 +2073,7 @@
       </p:grpSpPr>
       <p:pic>
         <p:nvPicPr>
-          <p:cNvPr id="2" name="Image 0" descr="preencoded.png">    </p:cNvPr>
+          <p:cNvPr id="2" name="Image 0" descr="preencoded.png"/>
           <p:cNvPicPr>
             <a:picLocks noChangeAspect="1"/>
           </p:cNvPicPr>
@@ -2229,7 +2229,7 @@
                 <a:ea typeface="Space Grotesk" pitchFamily="34" charset="-122"/>
                 <a:cs typeface="Space Grotesk" pitchFamily="34" charset="-120"/>
               </a:rPr>
-              <a:t> provides </a:t>
+              <a:t xml:space="preserve"> provides </a:t>
             </a:r>
             <a:r>
               <a:rPr lang="en-US" sz="900" b="1" dirty="0">
@@ -2251,7 +2251,7 @@
                 <a:ea typeface="Space Grotesk" pitchFamily="34" charset="-122"/>
                 <a:cs typeface="Space Grotesk" pitchFamily="34" charset="-120"/>
               </a:rPr>
-              <a:t> — the AI agent can resume work across sessions without losing context.</a:t>
+              <a:t xml:space="preserve"> — the AI agent can resume work across sessions without losing context.</a:t>
             </a:r>
             <a:endParaRPr lang="en-US" sz="1000" dirty="0"/>
           </a:p>
@@ -2306,7 +2306,7 @@
                 <a:ea typeface="Space Grotesk" pitchFamily="34" charset="-122"/>
                 <a:cs typeface="Space Grotesk" pitchFamily="34" charset="-120"/>
               </a:rPr>
-              <a:t> creates a </a:t>
+              <a:t xml:space="preserve"> creates a </a:t>
             </a:r>
             <a:r>
               <a:rPr lang="en-US" sz="900" b="1" dirty="0">
@@ -2328,7 +2328,7 @@
                 <a:ea typeface="Space Grotesk" pitchFamily="34" charset="-122"/>
                 <a:cs typeface="Space Grotesk" pitchFamily="34" charset="-120"/>
               </a:rPr>
-              <a:t> — every significant choice is recorded with its rationale, supporting audit and governance requirements.</a:t>
+              <a:t xml:space="preserve"> — every significant choice is recorded with its rationale, supporting audit and governance requirements.</a:t>
             </a:r>
             <a:endParaRPr lang="en-US" sz="1000" dirty="0"/>
           </a:p>
@@ -2383,7 +2383,7 @@
                 <a:ea typeface="Space Grotesk" pitchFamily="34" charset="-122"/>
                 <a:cs typeface="Space Grotesk" pitchFamily="34" charset="-120"/>
               </a:rPr>
-              <a:t> encodes </a:t>
+              <a:t xml:space="preserve"> encodes </a:t>
             </a:r>
             <a:r>
               <a:rPr lang="en-US" sz="900" b="1" dirty="0">
@@ -2405,7 +2405,7 @@
                 <a:ea typeface="Space Grotesk" pitchFamily="34" charset="-122"/>
                 <a:cs typeface="Space Grotesk" pitchFamily="34" charset="-120"/>
               </a:rPr>
-              <a:t> — coding standards, naming conventions, and compliance rules are stored as files the agent can read and enforce.</a:t>
+              <a:t xml:space="preserve"> — coding standards, naming conventions, and compliance rules are stored as files the agent can read and enforce.</a:t>
             </a:r>
             <a:endParaRPr lang="en-US" sz="1000" dirty="0"/>
           </a:p>
@@ -2460,7 +2460,7 @@
                 <a:ea typeface="Space Grotesk" pitchFamily="34" charset="-122"/>
                 <a:cs typeface="Space Grotesk" pitchFamily="34" charset="-120"/>
               </a:rPr>
-              <a:t> transforms the ICM repository into a </a:t>
+              <a:t xml:space="preserve"> transforms the ICM repository into a </a:t>
             </a:r>
             <a:r>
               <a:rPr lang="en-US" sz="900" b="1" dirty="0">
@@ -2482,7 +2482,7 @@
                 <a:ea typeface="Space Grotesk" pitchFamily="34" charset="-122"/>
                 <a:cs typeface="Space Grotesk" pitchFamily="34" charset="-120"/>
               </a:rPr>
-              <a:t> — every change to context, workflow, or standards is tracked over time.</a:t>
+              <a:t xml:space="preserve"> — every change to context, workflow, or standards is tracked over time.</a:t>
             </a:r>
             <a:endParaRPr lang="en-US" sz="900" dirty="0"/>
           </a:p>
@@ -2526,7 +2526,7 @@
                 <a:ea typeface="Space Grotesk" pitchFamily="34" charset="-122"/>
                 <a:cs typeface="Space Grotesk" pitchFamily="34" charset="-120"/>
               </a:rPr>
-              <a:t>ICM repositories should be treated as </a:t>
+              <a:t xml:space="preserve">ICM repositories should be treated as </a:t>
             </a:r>
             <a:r>
               <a:rPr lang="en-US" sz="1000" b="1" dirty="0">
@@ -2548,7 +2548,7 @@
                 <a:ea typeface="Space Grotesk" pitchFamily="34" charset="-122"/>
                 <a:cs typeface="Space Grotesk" pitchFamily="34" charset="-120"/>
               </a:rPr>
-              <a:t> — they are </a:t>
+              <a:t xml:space="preserve"> — they are </a:t>
             </a:r>
             <a:r>
               <a:rPr lang="en-US" sz="1050" dirty="0">
@@ -2559,7 +2559,7 @@
                 <a:ea typeface="Space Grotesk" pitchFamily="34" charset="-122"/>
                 <a:cs typeface="Space Grotesk" pitchFamily="34" charset="-120"/>
               </a:rPr>
-              <a:t>operational systems, not disposable </a:t>
+              <a:t xml:space="preserve">operational systems, not disposable </a:t>
             </a:r>
             <a:r>
               <a:rPr lang="en-US" sz="1050" dirty="0">
@@ -2741,7 +2741,7 @@
                 <a:ea typeface="monospace" pitchFamily="34" charset="-122"/>
                 <a:cs typeface="monospace" pitchFamily="34" charset="-120"/>
               </a:rPr>
-              <a:t>git commit -m "Initial ICM project </a:t>
+              <a:t xml:space="preserve">git commit -m "Initial ICM project </a:t>
             </a:r>
             <a:r>
               <a:rPr lang="en-US" sz="850" dirty="0">
@@ -2785,7 +2785,7 @@
       </p:grpSpPr>
       <p:pic>
         <p:nvPicPr>
-          <p:cNvPr id="2" name="Image 0" descr="preencoded.png">    </p:cNvPr>
+          <p:cNvPr id="2" name="Image 0" descr="preencoded.png"/>
           <p:cNvPicPr>
             <a:picLocks noChangeAspect="1"/>
           </p:cNvPicPr>
@@ -3599,7 +3599,7 @@
       </p:grpSpPr>
       <p:pic>
         <p:nvPicPr>
-          <p:cNvPr id="2" name="Image 0" descr="preencoded.png">    </p:cNvPr>
+          <p:cNvPr id="2" name="Image 0" descr="preencoded.png"/>
           <p:cNvPicPr>
             <a:picLocks noChangeAspect="1"/>
           </p:cNvPicPr>
@@ -3798,7 +3798,7 @@
                 <a:ea typeface="Space Grotesk" pitchFamily="34" charset="-122"/>
                 <a:cs typeface="Space Grotesk" pitchFamily="34" charset="-120"/>
               </a:rPr>
-              <a:t> — generic-agent-oriented-ICM for general projects; systems-engineering-ICM for engineering work.</a:t>
+              <a:t xml:space="preserve"> — generic-agent-oriented-ICM for general projects; systems-engineering-ICM for engineering work.</a:t>
             </a:r>
             <a:endParaRPr lang="en-US" sz="900" dirty="0"/>
           </a:p>
@@ -3855,7 +3855,7 @@
                 <a:ea typeface="Space Grotesk" pitchFamily="34" charset="-122"/>
                 <a:cs typeface="Space Grotesk" pitchFamily="34" charset="-120"/>
               </a:rPr>
-              <a:t> — provide the template folder and the AI instructions file.</a:t>
+              <a:t xml:space="preserve"> — point the AI agent at AI_PROJECT_CREATION_INSTRUCTIONS.md.</a:t>
             </a:r>
             <a:endParaRPr lang="en-US" sz="900" dirty="0"/>
           </a:p>
@@ -3912,7 +3912,7 @@
                 <a:ea typeface="Space Grotesk" pitchFamily="34" charset="-122"/>
                 <a:cs typeface="Space Grotesk" pitchFamily="34" charset="-120"/>
               </a:rPr>
-              <a:t> — project name, purpose, domain, technical stack, workflow stages.</a:t>
+              <a:t xml:space="preserve"> — project name, purpose, domain, technical stack, workflow stages.</a:t>
             </a:r>
             <a:endParaRPr lang="en-US" sz="900" dirty="0"/>
           </a:p>
@@ -3969,7 +3969,7 @@
                 <a:ea typeface="Space Grotesk" pitchFamily="34" charset="-122"/>
                 <a:cs typeface="Space Grotesk" pitchFamily="34" charset="-120"/>
               </a:rPr>
-              <a:t> — verify routing is unambiguous and ownership is explicit.</a:t>
+              <a:t xml:space="preserve"> — verify routing is unambiguous and ownership is explicit.</a:t>
             </a:r>
             <a:endParaRPr lang="en-US" sz="900" dirty="0"/>
           </a:p>
@@ -4204,7 +4204,7 @@
                 <a:ea typeface="Space Grotesk" pitchFamily="34" charset="-122"/>
                 <a:cs typeface="Space Grotesk" pitchFamily="34" charset="-120"/>
               </a:rPr>
-              <a:t> — point AI agents at the repository; they will self-route using context files.</a:t>
+              <a:t xml:space="preserve"> — point AI agents at the repository; they will self-route using context files.</a:t>
             </a:r>
             <a:endParaRPr lang="en-US" sz="900" dirty="0"/>
           </a:p>
@@ -4629,7 +4629,7 @@
       </p:grpSpPr>
       <p:pic>
         <p:nvPicPr>
-          <p:cNvPr id="2" name="Image 0" descr="preencoded.png">    </p:cNvPr>
+          <p:cNvPr id="2" name="Image 0" descr="preencoded.png"/>
           <p:cNvPicPr>
             <a:picLocks noChangeAspect="1"/>
           </p:cNvPicPr>
@@ -5029,7 +5029,7 @@
       </p:grpSpPr>
       <p:pic>
         <p:nvPicPr>
-          <p:cNvPr id="2" name="Image 0" descr="preencoded.png">    </p:cNvPr>
+          <p:cNvPr id="2" name="Image 0" descr="preencoded.png"/>
           <p:cNvPicPr>
             <a:picLocks noChangeAspect="1"/>
           </p:cNvPicPr>
@@ -5435,7 +5435,7 @@
                 <a:ea typeface="Space Grotesk" pitchFamily="34" charset="-122"/>
                 <a:cs typeface="Space Grotesk" pitchFamily="34" charset="-120"/>
               </a:rPr>
-              <a:t>The folder structure itself </a:t>
+              <a:t xml:space="preserve">The folder structure itself </a:t>
             </a:r>
             <a:r>
               <a:rPr lang="en-US" sz="850" i="1" dirty="0">
@@ -5457,7 +5457,7 @@
                 <a:ea typeface="Space Grotesk" pitchFamily="34" charset="-122"/>
                 <a:cs typeface="Space Grotesk" pitchFamily="34" charset="-120"/>
               </a:rPr>
-              <a:t> the workflow </a:t>
+              <a:t xml:space="preserve"> the workflow </a:t>
             </a:r>
             <a:r>
               <a:rPr lang="en-US" sz="850" dirty="0">
@@ -5468,7 +5468,7 @@
                 <a:ea typeface="Space Grotesk" pitchFamily="34" charset="-122"/>
                 <a:cs typeface="Space Grotesk" pitchFamily="34" charset="-120"/>
               </a:rPr>
-              <a:t>engine: folder names, file names, and file </a:t>
+              <a:t xml:space="preserve">engine: folder names, file names, and file </a:t>
             </a:r>
             <a:r>
               <a:rPr lang="en-US" sz="850" dirty="0">
@@ -5479,7 +5479,7 @@
                 <a:ea typeface="Space Grotesk" pitchFamily="34" charset="-122"/>
                 <a:cs typeface="Space Grotesk" pitchFamily="34" charset="-120"/>
               </a:rPr>
-              <a:t>contents collectively define what the </a:t>
+              <a:t xml:space="preserve">contents collectively define what the </a:t>
             </a:r>
             <a:r>
               <a:rPr lang="en-US" sz="850" dirty="0">
@@ -5698,7 +5698,7 @@
       </p:grpSpPr>
       <p:pic>
         <p:nvPicPr>
-          <p:cNvPr id="2" name="Image 0" descr="preencoded.png">    </p:cNvPr>
+          <p:cNvPr id="2" name="Image 0" descr="preencoded.png"/>
           <p:cNvPicPr>
             <a:picLocks noChangeAspect="1"/>
           </p:cNvPicPr>
@@ -6298,7 +6298,7 @@
       </p:grpSpPr>
       <p:pic>
         <p:nvPicPr>
-          <p:cNvPr id="2" name="Image 0" descr="preencoded.png">    </p:cNvPr>
+          <p:cNvPr id="2" name="Image 0" descr="preencoded.png"/>
           <p:cNvPicPr>
             <a:picLocks noChangeAspect="1"/>
           </p:cNvPicPr>
@@ -7128,7 +7128,7 @@
       </p:grpSpPr>
       <p:pic>
         <p:nvPicPr>
-          <p:cNvPr id="2" name="Image 0" descr="preencoded.png">    </p:cNvPr>
+          <p:cNvPr id="2" name="Image 0" descr="preencoded.png"/>
           <p:cNvPicPr>
             <a:picLocks noChangeAspect="1"/>
           </p:cNvPicPr>
@@ -7998,7 +7998,7 @@
       </p:grpSpPr>
       <p:pic>
         <p:nvPicPr>
-          <p:cNvPr id="2" name="Image 0" descr="preencoded.png">    </p:cNvPr>
+          <p:cNvPr id="2" name="Image 0" descr="preencoded.png"/>
           <p:cNvPicPr>
             <a:picLocks noChangeAspect="1"/>
           </p:cNvPicPr>
@@ -9586,7 +9586,7 @@
       </p:grpSpPr>
       <p:pic>
         <p:nvPicPr>
-          <p:cNvPr id="2" name="Image 0" descr="preencoded.png">    </p:cNvPr>
+          <p:cNvPr id="2" name="Image 0" descr="preencoded.png"/>
           <p:cNvPicPr>
             <a:picLocks noChangeAspect="1"/>
           </p:cNvPicPr>
@@ -9813,7 +9813,7 @@
                 <a:ea typeface="Space Grotesk" pitchFamily="34" charset="-122"/>
                 <a:cs typeface="Space Grotesk" pitchFamily="34" charset="-120"/>
               </a:rPr>
-              <a:t>Choose </a:t>
+              <a:t xml:space="preserve">Choose </a:t>
             </a:r>
             <a:r>
               <a:rPr lang="en-US" sz="800" b="1" dirty="0">
@@ -9835,7 +9835,7 @@
                 <a:ea typeface="Space Grotesk" pitchFamily="34" charset="-122"/>
                 <a:cs typeface="Space Grotesk" pitchFamily="34" charset="-120"/>
               </a:rPr>
-              <a:t> for general projects or </a:t>
+              <a:t xml:space="preserve"> for general projects or </a:t>
             </a:r>
             <a:r>
               <a:rPr lang="en-US" sz="800" b="1" dirty="0">
@@ -9857,7 +9857,7 @@
                 <a:ea typeface="Space Grotesk" pitchFamily="34" charset="-122"/>
                 <a:cs typeface="Space Grotesk" pitchFamily="34" charset="-120"/>
               </a:rPr>
-              <a:t> for engineering-intensive work.</a:t>
+              <a:t xml:space="preserve"> for engineering-intensive work.</a:t>
             </a:r>
             <a:endParaRPr lang="en-US" sz="850" dirty="0"/>
           </a:p>
@@ -9983,7 +9983,7 @@
                 <a:ea typeface="Space Grotesk" pitchFamily="34" charset="-122"/>
                 <a:cs typeface="Space Grotesk" pitchFamily="34" charset="-120"/>
               </a:rPr>
-              <a:t>Point the AI at the selected template and instruct it to read ICM.md, CONTEXT.md, local workspace CONTEXT.md, and local AGENT.md.</a:t>
+              <a:t>Point the AI agent at AI_PROJECT_CREATION_INSTRUCTIONS.md.</a:t>
             </a:r>
             <a:endParaRPr lang="en-US" sz="850" dirty="0"/>
           </a:p>
@@ -10394,7 +10394,7 @@
       </p:grpSpPr>
       <p:pic>
         <p:nvPicPr>
-          <p:cNvPr id="2" name="Image 0" descr="preencoded.png">    </p:cNvPr>
+          <p:cNvPr id="2" name="Image 0" descr="preencoded.png"/>
           <p:cNvPicPr>
             <a:picLocks noChangeAspect="1"/>
           </p:cNvPicPr>

</xml_diff>

<commit_message>
Sync PPTX and PDF with latest content updates
Co-Authored-By: Claude Sonnet 4.6 <noreply@anthropic.com>
</commit_message>
<xml_diff>
--- a/Interpretable_Context_Methodology_(ICM).pptx
+++ b/Interpretable_Context_Methodology_(ICM).pptx
@@ -4,6 +4,9 @@
   <p:sldMasterIdLst>
     <p:sldMasterId id="2147483648" r:id="rId1"/>
   </p:sldMasterIdLst>
+  <p:notesMasterIdLst>
+    <p:notesMasterId r:id="rId14"/>
+  </p:notesMasterIdLst>
   <p:sldIdLst>
     <p:sldId id="256" r:id="rId2"/>
     <p:sldId id="257" r:id="rId3"/>
@@ -18,10 +21,7 @@
     <p:sldId id="266" r:id="rId12"/>
     <p:sldId id="267" r:id="rId13"/>
   </p:sldIdLst>
-  <p:notesMasterIdLst>
-    <p:notesMasterId r:id="rId14"/>
-  </p:notesMasterIdLst>
-  <p:sldSz cx="9144000" cy="5143500"/>
+  <p:sldSz cx="9144000" cy="5143500" type="screen16x9"/>
   <p:notesSz cx="5143500" cy="9144000"/>
   <p:defaultTextStyle>
     <a:lvl1pPr marL="0" algn="l" defTabSz="914400" rtl="0" eaLnBrk="1" latinLnBrk="0" hangingPunct="1">
@@ -115,6 +115,11 @@
       </a:defRPr>
     </a:lvl9pPr>
   </p:defaultTextStyle>
+  <p:extLst>
+    <p:ext uri="{EFAFB233-063F-42B5-8137-9DF3F51BA10A}">
+      <p15:sldGuideLst xmlns:p15="http://schemas.microsoft.com/office/powerpoint/2012/main"/>
+    </p:ext>
+  </p:extLst>
 </p:presentation>
 </file>
 
@@ -140,234 +145,10 @@
           <a:chExt cx="0" cy="0"/>
         </a:xfrm>
       </p:grpSpPr>
-      <p:sp>
-        <p:nvSpPr>
-          <p:cNvPr id="2" name="Header Placeholder 1"/>
-          <p:cNvSpPr>
-            <a:spLocks noGrp="1"/>
-          </p:cNvSpPr>
-          <p:nvPr>
-            <p:ph type="hdr" sz="quarter"/>
-          </p:nvPr>
-        </p:nvSpPr>
-        <p:spPr>
-          <a:xfrm>
-            <a:off x="0" y="0"/>
-            <a:ext cx="2971800" cy="458788"/>
-          </a:xfrm>
-          <a:prstGeom prst="rect">
-            <a:avLst/>
-          </a:prstGeom>
-        </p:spPr>
-        <p:txBody>
-          <a:bodyPr vert="horz" lIns="91440" tIns="45720" rIns="91440" bIns="45720" rtlCol="0"/>
-          <a:lstStyle>
-            <a:lvl1pPr algn="l">
-              <a:defRPr sz="1200"/>
-            </a:lvl1pPr>
-          </a:lstStyle>
-          <a:p>
-            <a:endParaRPr lang="en-US"/>
-          </a:p>
-        </p:txBody>
-      </p:sp>
-      <p:sp>
-        <p:nvSpPr>
-          <p:cNvPr id="3" name="Date Placeholder 2"/>
-          <p:cNvSpPr>
-            <a:spLocks noGrp="1"/>
-          </p:cNvSpPr>
-          <p:nvPr>
-            <p:ph type="dt" idx="1"/>
-          </p:nvPr>
-        </p:nvSpPr>
-        <p:spPr>
-          <a:xfrm>
-            <a:off x="3884613" y="0"/>
-            <a:ext cx="2971800" cy="458788"/>
-          </a:xfrm>
-          <a:prstGeom prst="rect">
-            <a:avLst/>
-          </a:prstGeom>
-        </p:spPr>
-        <p:txBody>
-          <a:bodyPr vert="horz" lIns="91440" tIns="45720" rIns="91440" bIns="45720" rtlCol="0"/>
-          <a:lstStyle>
-            <a:lvl1pPr algn="r">
-              <a:defRPr sz="1200"/>
-            </a:lvl1pPr>
-          </a:lstStyle>
-          <a:p>
-            <a:fld id="{5282F153-3F37-0F45-9E97-73ACFA13230C}" type="datetimeFigureOut">
-              <a:rPr lang="en-US"/>
-              <a:t>7/23/19</a:t>
-            </a:fld>
-            <a:endParaRPr lang="en-US"/>
-          </a:p>
-        </p:txBody>
-      </p:sp>
-      <p:sp>
-        <p:nvSpPr>
-          <p:cNvPr id="4" name="Slide Image Placeholder 3"/>
-          <p:cNvSpPr>
-            <a:spLocks noGrp="1" noRot="1" noChangeAspect="1"/>
-          </p:cNvSpPr>
-          <p:nvPr>
-            <p:ph type="sldImg" idx="2"/>
-          </p:nvPr>
-        </p:nvSpPr>
-        <p:spPr>
-          <a:xfrm>
-            <a:off x="685800" y="1143000"/>
-            <a:ext cx="5486400" cy="3086100"/>
-          </a:xfrm>
-          <a:prstGeom prst="rect">
-            <a:avLst/>
-          </a:prstGeom>
-          <a:noFill/>
-          <a:ln w="12700">
-            <a:solidFill>
-              <a:prstClr val="black"/>
-            </a:solidFill>
-          </a:ln>
-        </p:spPr>
-        <p:txBody>
-          <a:bodyPr vert="horz" lIns="91440" tIns="45720" rIns="91440" bIns="45720" rtlCol="0" anchor="ctr"/>
-          <a:lstStyle/>
-          <a:p>
-            <a:endParaRPr lang="en-US"/>
-          </a:p>
-        </p:txBody>
-      </p:sp>
-      <p:sp>
-        <p:nvSpPr>
-          <p:cNvPr id="5" name="Notes Placeholder 4"/>
-          <p:cNvSpPr>
-            <a:spLocks noGrp="1"/>
-          </p:cNvSpPr>
-          <p:nvPr>
-            <p:ph type="body" sz="quarter" idx="3"/>
-          </p:nvPr>
-        </p:nvSpPr>
-        <p:spPr>
-          <a:xfrm>
-            <a:off x="685800" y="4400550"/>
-            <a:ext cx="5486400" cy="3600450"/>
-          </a:xfrm>
-          <a:prstGeom prst="rect">
-            <a:avLst/>
-          </a:prstGeom>
-        </p:spPr>
-        <p:txBody>
-          <a:bodyPr vert="horz" lIns="91440" tIns="45720" rIns="91440" bIns="45720" rtlCol="0"/>
-          <a:lstStyle/>
-          <a:p>
-            <a:pPr lvl="0"/>
-            <a:r>
-              <a:rPr lang="en-US"/>
-              <a:t>Click to edit Master text styles</a:t>
-            </a:r>
-          </a:p>
-          <a:p>
-            <a:pPr lvl="1"/>
-            <a:r>
-              <a:rPr lang="en-US"/>
-              <a:t>Second level</a:t>
-            </a:r>
-          </a:p>
-          <a:p>
-            <a:pPr lvl="2"/>
-            <a:r>
-              <a:rPr lang="en-US"/>
-              <a:t>Third level</a:t>
-            </a:r>
-          </a:p>
-          <a:p>
-            <a:pPr lvl="3"/>
-            <a:r>
-              <a:rPr lang="en-US"/>
-              <a:t>Fourth level</a:t>
-            </a:r>
-          </a:p>
-          <a:p>
-            <a:pPr lvl="4"/>
-            <a:r>
-              <a:rPr lang="en-US"/>
-              <a:t>Fifth level</a:t>
-            </a:r>
-          </a:p>
-        </p:txBody>
-      </p:sp>
-      <p:sp>
-        <p:nvSpPr>
-          <p:cNvPr id="6" name="Footer Placeholder 5"/>
-          <p:cNvSpPr>
-            <a:spLocks noGrp="1"/>
-          </p:cNvSpPr>
-          <p:nvPr>
-            <p:ph type="ftr" sz="quarter" idx="4"/>
-          </p:nvPr>
-        </p:nvSpPr>
-        <p:spPr>
-          <a:xfrm>
-            <a:off x="0" y="8685213"/>
-            <a:ext cx="2971800" cy="458787"/>
-          </a:xfrm>
-          <a:prstGeom prst="rect">
-            <a:avLst/>
-          </a:prstGeom>
-        </p:spPr>
-        <p:txBody>
-          <a:bodyPr vert="horz" lIns="91440" tIns="45720" rIns="91440" bIns="45720" rtlCol="0" anchor="b"/>
-          <a:lstStyle>
-            <a:lvl1pPr algn="l">
-              <a:defRPr sz="1200"/>
-            </a:lvl1pPr>
-          </a:lstStyle>
-          <a:p>
-            <a:endParaRPr lang="en-US"/>
-          </a:p>
-        </p:txBody>
-      </p:sp>
-      <p:sp>
-        <p:nvSpPr>
-          <p:cNvPr id="7" name="Slide Number Placeholder 6"/>
-          <p:cNvSpPr>
-            <a:spLocks noGrp="1"/>
-          </p:cNvSpPr>
-          <p:nvPr>
-            <p:ph type="sldNum" sz="quarter" idx="5"/>
-          </p:nvPr>
-        </p:nvSpPr>
-        <p:spPr>
-          <a:xfrm>
-            <a:off x="3884613" y="8685213"/>
-            <a:ext cx="2971800" cy="458787"/>
-          </a:xfrm>
-          <a:prstGeom prst="rect">
-            <a:avLst/>
-          </a:prstGeom>
-        </p:spPr>
-        <p:txBody>
-          <a:bodyPr vert="horz" lIns="91440" tIns="45720" rIns="91440" bIns="45720" rtlCol="0" anchor="b"/>
-          <a:lstStyle>
-            <a:lvl1pPr algn="r">
-              <a:defRPr sz="1200"/>
-            </a:lvl1pPr>
-          </a:lstStyle>
-          <a:p>
-            <a:fld id="{CE5E9CC1-C706-0F49-92D6-E571CC5EEA8F}" type="slidenum">
-              <a:rPr lang="en-US"/>
-              <a:t>‹#›</a:t>
-            </a:fld>
-            <a:endParaRPr lang="en-US"/>
-          </a:p>
-        </p:txBody>
-      </p:sp>
     </p:spTree>
     <p:extLst>
       <p:ext uri="{BB962C8B-B14F-4D97-AF65-F5344CB8AC3E}">
-        <p14:creationId xmlns:p14="http://schemas.microsoft.com/office/powerpoint/2010/main" val="1024086991"/>
+        <p14:creationId xmlns:p14="http://schemas.microsoft.com/office/powerpoint/2010/main" val="1961109430"/>
       </p:ext>
     </p:extLst>
   </p:cSld>
@@ -511,10 +292,6 @@
           <a:bodyPr/>
           <a:lstStyle/>
           <a:p>
-            <a:r>
-              <a:rPr lang="en-US" dirty="0"/>
-              <a:t/>
-            </a:r>
             <a:endParaRPr lang="en-US" dirty="0"/>
           </a:p>
         </p:txBody>
@@ -599,10 +376,6 @@
           <a:bodyPr/>
           <a:lstStyle/>
           <a:p>
-            <a:r>
-              <a:rPr lang="en-US" dirty="0"/>
-              <a:t/>
-            </a:r>
             <a:endParaRPr lang="en-US" dirty="0"/>
           </a:p>
         </p:txBody>
@@ -687,10 +460,6 @@
           <a:bodyPr/>
           <a:lstStyle/>
           <a:p>
-            <a:r>
-              <a:rPr lang="en-US" dirty="0"/>
-              <a:t/>
-            </a:r>
             <a:endParaRPr lang="en-US" dirty="0"/>
           </a:p>
         </p:txBody>
@@ -775,10 +544,6 @@
           <a:bodyPr/>
           <a:lstStyle/>
           <a:p>
-            <a:r>
-              <a:rPr lang="en-US" dirty="0"/>
-              <a:t/>
-            </a:r>
             <a:endParaRPr lang="en-US" dirty="0"/>
           </a:p>
         </p:txBody>
@@ -863,10 +628,6 @@
           <a:bodyPr/>
           <a:lstStyle/>
           <a:p>
-            <a:r>
-              <a:rPr lang="en-US" dirty="0"/>
-              <a:t/>
-            </a:r>
             <a:endParaRPr lang="en-US" dirty="0"/>
           </a:p>
         </p:txBody>
@@ -951,10 +712,6 @@
           <a:bodyPr/>
           <a:lstStyle/>
           <a:p>
-            <a:r>
-              <a:rPr lang="en-US" dirty="0"/>
-              <a:t/>
-            </a:r>
             <a:endParaRPr lang="en-US" dirty="0"/>
           </a:p>
         </p:txBody>
@@ -1039,10 +796,6 @@
           <a:bodyPr/>
           <a:lstStyle/>
           <a:p>
-            <a:r>
-              <a:rPr lang="en-US" dirty="0"/>
-              <a:t/>
-            </a:r>
             <a:endParaRPr lang="en-US" dirty="0"/>
           </a:p>
         </p:txBody>
@@ -1127,10 +880,6 @@
           <a:bodyPr/>
           <a:lstStyle/>
           <a:p>
-            <a:r>
-              <a:rPr lang="en-US" dirty="0"/>
-              <a:t/>
-            </a:r>
             <a:endParaRPr lang="en-US" dirty="0"/>
           </a:p>
         </p:txBody>
@@ -1215,10 +964,6 @@
           <a:bodyPr/>
           <a:lstStyle/>
           <a:p>
-            <a:r>
-              <a:rPr lang="en-US" dirty="0"/>
-              <a:t/>
-            </a:r>
             <a:endParaRPr lang="en-US" dirty="0"/>
           </a:p>
         </p:txBody>
@@ -1303,10 +1048,6 @@
           <a:bodyPr/>
           <a:lstStyle/>
           <a:p>
-            <a:r>
-              <a:rPr lang="en-US" dirty="0"/>
-              <a:t/>
-            </a:r>
             <a:endParaRPr lang="en-US" dirty="0"/>
           </a:p>
         </p:txBody>
@@ -1391,10 +1132,6 @@
           <a:bodyPr/>
           <a:lstStyle/>
           <a:p>
-            <a:r>
-              <a:rPr lang="en-US" dirty="0"/>
-              <a:t/>
-            </a:r>
             <a:endParaRPr lang="en-US" dirty="0"/>
           </a:p>
         </p:txBody>
@@ -1479,10 +1216,6 @@
           <a:bodyPr/>
           <a:lstStyle/>
           <a:p>
-            <a:r>
-              <a:rPr lang="en-US" dirty="0"/>
-              <a:t/>
-            </a:r>
             <a:endParaRPr lang="en-US" dirty="0"/>
           </a:p>
         </p:txBody>
@@ -1556,6 +1289,11 @@
 <file path=ppt/slideMasters/slideMaster1.xml><?xml version="1.0" encoding="utf-8"?>
 <p:sldMaster xmlns:a="http://schemas.openxmlformats.org/drawingml/2006/main" xmlns:r="http://schemas.openxmlformats.org/officeDocument/2006/relationships" xmlns:p="http://schemas.openxmlformats.org/presentationml/2006/main">
   <p:cSld>
+    <p:bg>
+      <p:bgRef idx="1001">
+        <a:schemeClr val="bg1"/>
+      </p:bgRef>
+    </p:bg>
     <p:spTree>
       <p:nvGrpSpPr>
         <p:cNvPr id="1" name=""/>
@@ -1856,7 +1594,7 @@
           <p:nvPr/>
         </p:nvPicPr>
         <p:blipFill>
-          <a:blip r:embed="rId1"/>
+          <a:blip r:embed="rId3"/>
           <a:stretch>
             <a:fillRect/>
           </a:stretch>
@@ -1894,7 +1632,7 @@
           </a:bodyPr>
           <a:lstStyle/>
           <a:p>
-            <a:pPr algn="l" indent="0" marL="0">
+            <a:pPr marL="0" indent="0" algn="l">
               <a:lnSpc>
                 <a:spcPct val="88000"/>
               </a:lnSpc>
@@ -1909,30 +1647,8 @@
                 <a:ea typeface="Space Grotesk" pitchFamily="34" charset="-122"/>
                 <a:cs typeface="Space Grotesk" pitchFamily="34" charset="-120"/>
               </a:rPr>
-              <a:t>Interpretable Context</a:t>
-            </a:r>
-            <a:r>
-              <a:rPr lang="en-US" sz="3300" b="1" dirty="0">
-                <a:solidFill>
-                  <a:srgbClr val="111111"/>
-                </a:solidFill>
-                <a:latin typeface="Space Grotesk" pitchFamily="34" charset="0"/>
-                <a:ea typeface="Space Grotesk" pitchFamily="34" charset="-122"/>
-                <a:cs typeface="Space Grotesk" pitchFamily="34" charset="-120"/>
-              </a:rPr>
-              <a:t>
-</a:t>
-            </a:r>
-            <a:r>
-              <a:rPr lang="en-US" sz="3300" b="1" dirty="0">
-                <a:solidFill>
-                  <a:srgbClr val="111111"/>
-                </a:solidFill>
-                <a:latin typeface="Space Grotesk" pitchFamily="34" charset="0"/>
-                <a:ea typeface="Space Grotesk" pitchFamily="34" charset="-122"/>
-                <a:cs typeface="Space Grotesk" pitchFamily="34" charset="-120"/>
-              </a:rPr>
-              <a:t>Methodology (ICM)</a:t>
+              <a:t>Interpretable Context
+Methodology (ICM)</a:t>
             </a:r>
             <a:endParaRPr lang="en-US" sz="3300" dirty="0"/>
           </a:p>
@@ -1961,7 +1677,7 @@
           </a:bodyPr>
           <a:lstStyle/>
           <a:p>
-            <a:pPr algn="l" indent="0" marL="0">
+            <a:pPr marL="0" indent="0" algn="l">
               <a:lnSpc>
                 <a:spcPct val="112000"/>
               </a:lnSpc>
@@ -1976,30 +1692,8 @@
                 <a:ea typeface="Space Grotesk" pitchFamily="34" charset="-122"/>
                 <a:cs typeface="Space Grotesk" pitchFamily="34" charset="-120"/>
               </a:rPr>
-              <a:t>Orchestrating AI Agent Workflows with</a:t>
-            </a:r>
-            <a:r>
-              <a:rPr lang="en-US" sz="1700" dirty="0">
-                <a:solidFill>
-                  <a:srgbClr val="333333"/>
-                </a:solidFill>
-                <a:latin typeface="Space Grotesk" pitchFamily="34" charset="0"/>
-                <a:ea typeface="Space Grotesk" pitchFamily="34" charset="-122"/>
-                <a:cs typeface="Space Grotesk" pitchFamily="34" charset="-120"/>
-              </a:rPr>
-              <a:t>
-</a:t>
-            </a:r>
-            <a:r>
-              <a:rPr lang="en-US" sz="1700" dirty="0">
-                <a:solidFill>
-                  <a:srgbClr val="333333"/>
-                </a:solidFill>
-                <a:latin typeface="Space Grotesk" pitchFamily="34" charset="0"/>
-                <a:ea typeface="Space Grotesk" pitchFamily="34" charset="-122"/>
-                <a:cs typeface="Space Grotesk" pitchFamily="34" charset="-120"/>
-              </a:rPr>
-              <a:t>Folders, Files, and Structure</a:t>
+              <a:t>Orchestrating AI Agent Workflows with
+Folders, Files, and Structure</a:t>
             </a:r>
             <a:endParaRPr lang="en-US" sz="1700" dirty="0"/>
           </a:p>
@@ -2028,7 +1722,7 @@
           </a:bodyPr>
           <a:lstStyle/>
           <a:p>
-            <a:pPr algn="l" indent="0" marL="0">
+            <a:pPr marL="0" indent="0" algn="l">
               <a:buNone/>
             </a:pPr>
             <a:r>
@@ -2080,7 +1774,7 @@
           <p:nvPr/>
         </p:nvPicPr>
         <p:blipFill>
-          <a:blip r:embed="rId1"/>
+          <a:blip r:embed="rId3"/>
           <a:stretch>
             <a:fillRect/>
           </a:stretch>
@@ -2118,7 +1812,7 @@
           </a:bodyPr>
           <a:lstStyle/>
           <a:p>
-            <a:pPr algn="l" indent="0" marL="0">
+            <a:pPr marL="0" indent="0" algn="l">
               <a:buNone/>
             </a:pPr>
             <a:r>
@@ -2159,7 +1853,7 @@
           </a:bodyPr>
           <a:lstStyle/>
           <a:p>
-            <a:pPr algn="l" indent="0" marL="0">
+            <a:pPr marL="0" indent="0" algn="l">
               <a:lnSpc>
                 <a:spcPct val="112000"/>
               </a:lnSpc>
@@ -2203,7 +1897,7 @@
           </a:bodyPr>
           <a:lstStyle/>
           <a:p>
-            <a:pPr algn="l" indent="0" marL="0">
+            <a:pPr marL="0" indent="0" algn="l">
               <a:lnSpc>
                 <a:spcPct val="108000"/>
               </a:lnSpc>
@@ -2229,7 +1923,7 @@
                 <a:ea typeface="Space Grotesk" pitchFamily="34" charset="-122"/>
                 <a:cs typeface="Space Grotesk" pitchFamily="34" charset="-120"/>
               </a:rPr>
-              <a:t xml:space="preserve"> provides </a:t>
+              <a:t> provides </a:t>
             </a:r>
             <a:r>
               <a:rPr lang="en-US" sz="900" b="1" dirty="0">
@@ -2251,7 +1945,7 @@
                 <a:ea typeface="Space Grotesk" pitchFamily="34" charset="-122"/>
                 <a:cs typeface="Space Grotesk" pitchFamily="34" charset="-120"/>
               </a:rPr>
-              <a:t xml:space="preserve"> — the AI agent can resume work across sessions without losing context.</a:t>
+              <a:t> — the AI agent can resume work across sessions without losing context.</a:t>
             </a:r>
             <a:endParaRPr lang="en-US" sz="1000" dirty="0"/>
           </a:p>
@@ -2280,7 +1974,7 @@
           </a:bodyPr>
           <a:lstStyle/>
           <a:p>
-            <a:pPr algn="l" indent="0" marL="0">
+            <a:pPr marL="0" indent="0" algn="l">
               <a:lnSpc>
                 <a:spcPct val="108000"/>
               </a:lnSpc>
@@ -2306,7 +2000,7 @@
                 <a:ea typeface="Space Grotesk" pitchFamily="34" charset="-122"/>
                 <a:cs typeface="Space Grotesk" pitchFamily="34" charset="-120"/>
               </a:rPr>
-              <a:t xml:space="preserve"> creates a </a:t>
+              <a:t> creates a </a:t>
             </a:r>
             <a:r>
               <a:rPr lang="en-US" sz="900" b="1" dirty="0">
@@ -2328,7 +2022,7 @@
                 <a:ea typeface="Space Grotesk" pitchFamily="34" charset="-122"/>
                 <a:cs typeface="Space Grotesk" pitchFamily="34" charset="-120"/>
               </a:rPr>
-              <a:t xml:space="preserve"> — every significant choice is recorded with its rationale, supporting audit and governance requirements.</a:t>
+              <a:t> — every significant choice is recorded with its rationale, supporting audit and governance requirements.</a:t>
             </a:r>
             <a:endParaRPr lang="en-US" sz="1000" dirty="0"/>
           </a:p>
@@ -2357,7 +2051,7 @@
           </a:bodyPr>
           <a:lstStyle/>
           <a:p>
-            <a:pPr algn="l" indent="0" marL="0">
+            <a:pPr marL="0" indent="0" algn="l">
               <a:lnSpc>
                 <a:spcPct val="108000"/>
               </a:lnSpc>
@@ -2383,7 +2077,7 @@
                 <a:ea typeface="Space Grotesk" pitchFamily="34" charset="-122"/>
                 <a:cs typeface="Space Grotesk" pitchFamily="34" charset="-120"/>
               </a:rPr>
-              <a:t xml:space="preserve"> encodes </a:t>
+              <a:t> encodes </a:t>
             </a:r>
             <a:r>
               <a:rPr lang="en-US" sz="900" b="1" dirty="0">
@@ -2405,7 +2099,7 @@
                 <a:ea typeface="Space Grotesk" pitchFamily="34" charset="-122"/>
                 <a:cs typeface="Space Grotesk" pitchFamily="34" charset="-120"/>
               </a:rPr>
-              <a:t xml:space="preserve"> — coding standards, naming conventions, and compliance rules are stored as files the agent can read and enforce.</a:t>
+              <a:t> — coding standards, naming conventions, and compliance rules are stored as files the agent can read and enforce.</a:t>
             </a:r>
             <a:endParaRPr lang="en-US" sz="1000" dirty="0"/>
           </a:p>
@@ -2434,7 +2128,7 @@
           </a:bodyPr>
           <a:lstStyle/>
           <a:p>
-            <a:pPr algn="l" indent="0" marL="0">
+            <a:pPr marL="0" indent="0" algn="l">
               <a:lnSpc>
                 <a:spcPct val="120000"/>
               </a:lnSpc>
@@ -2460,7 +2154,7 @@
                 <a:ea typeface="Space Grotesk" pitchFamily="34" charset="-122"/>
                 <a:cs typeface="Space Grotesk" pitchFamily="34" charset="-120"/>
               </a:rPr>
-              <a:t xml:space="preserve"> transforms the ICM repository into a </a:t>
+              <a:t> transforms the ICM repository into a </a:t>
             </a:r>
             <a:r>
               <a:rPr lang="en-US" sz="900" b="1" dirty="0">
@@ -2482,7 +2176,7 @@
                 <a:ea typeface="Space Grotesk" pitchFamily="34" charset="-122"/>
                 <a:cs typeface="Space Grotesk" pitchFamily="34" charset="-120"/>
               </a:rPr>
-              <a:t xml:space="preserve"> — every change to context, workflow, or standards is tracked over time.</a:t>
+              <a:t> — every change to context, workflow, or standards is tracked over time.</a:t>
             </a:r>
             <a:endParaRPr lang="en-US" sz="900" dirty="0"/>
           </a:p>
@@ -2511,7 +2205,7 @@
           </a:bodyPr>
           <a:lstStyle/>
           <a:p>
-            <a:pPr algn="l" indent="0" marL="0">
+            <a:pPr marL="0" indent="0" algn="l">
               <a:lnSpc>
                 <a:spcPct val="112000"/>
               </a:lnSpc>
@@ -2526,7 +2220,7 @@
                 <a:ea typeface="Space Grotesk" pitchFamily="34" charset="-122"/>
                 <a:cs typeface="Space Grotesk" pitchFamily="34" charset="-120"/>
               </a:rPr>
-              <a:t xml:space="preserve">ICM repositories should be treated as </a:t>
+              <a:t>ICM repositories should be treated as </a:t>
             </a:r>
             <a:r>
               <a:rPr lang="en-US" sz="1000" b="1" dirty="0">
@@ -2548,29 +2242,7 @@
                 <a:ea typeface="Space Grotesk" pitchFamily="34" charset="-122"/>
                 <a:cs typeface="Space Grotesk" pitchFamily="34" charset="-120"/>
               </a:rPr>
-              <a:t xml:space="preserve"> — they are </a:t>
-            </a:r>
-            <a:r>
-              <a:rPr lang="en-US" sz="1050" dirty="0">
-                <a:solidFill>
-                  <a:srgbClr val="111111"/>
-                </a:solidFill>
-                <a:latin typeface="Space Grotesk" pitchFamily="34" charset="0"/>
-                <a:ea typeface="Space Grotesk" pitchFamily="34" charset="-122"/>
-                <a:cs typeface="Space Grotesk" pitchFamily="34" charset="-120"/>
-              </a:rPr>
-              <a:t xml:space="preserve">operational systems, not disposable </a:t>
-            </a:r>
-            <a:r>
-              <a:rPr lang="en-US" sz="1050" dirty="0">
-                <a:solidFill>
-                  <a:srgbClr val="111111"/>
-                </a:solidFill>
-                <a:latin typeface="Space Grotesk" pitchFamily="34" charset="0"/>
-                <a:ea typeface="Space Grotesk" pitchFamily="34" charset="-122"/>
-                <a:cs typeface="Space Grotesk" pitchFamily="34" charset="-120"/>
-              </a:rPr>
-              <a:t>scaffolds.</a:t>
+              <a:t> — they are operational systems, not disposable scaffolds.</a:t>
             </a:r>
             <a:endParaRPr lang="en-US" sz="1050" dirty="0"/>
           </a:p>
@@ -2599,7 +2271,7 @@
           </a:bodyPr>
           <a:lstStyle/>
           <a:p>
-            <a:pPr algn="l" indent="0" marL="0">
+            <a:pPr marL="0" indent="0" algn="l">
               <a:buNone/>
             </a:pPr>
             <a:r>
@@ -2636,6 +2308,13 @@
           </a:solidFill>
           <a:ln/>
         </p:spPr>
+        <p:txBody>
+          <a:bodyPr/>
+          <a:lstStyle/>
+          <a:p>
+            <a:endParaRPr lang="en-US"/>
+          </a:p>
+        </p:txBody>
       </p:sp>
       <p:sp>
         <p:nvSpPr>
@@ -2656,6 +2335,13 @@
           </a:solidFill>
           <a:ln/>
         </p:spPr>
+        <p:txBody>
+          <a:bodyPr/>
+          <a:lstStyle/>
+          <a:p>
+            <a:endParaRPr lang="en-US"/>
+          </a:p>
+        </p:txBody>
       </p:sp>
       <p:sp>
         <p:nvSpPr>
@@ -2680,7 +2366,7 @@
           </a:bodyPr>
           <a:lstStyle/>
           <a:p>
-            <a:pPr algn="l" indent="0" marL="0">
+            <a:pPr marL="0" indent="0" algn="l">
               <a:lnSpc>
                 <a:spcPct val="128000"/>
               </a:lnSpc>
@@ -2695,64 +2381,9 @@
                 <a:ea typeface="monospace" pitchFamily="34" charset="-122"/>
                 <a:cs typeface="monospace" pitchFamily="34" charset="-120"/>
               </a:rPr>
-              <a:t>git init</a:t>
-            </a:r>
-            <a:r>
-              <a:rPr lang="en-US" sz="850" dirty="0">
-                <a:solidFill>
-                  <a:srgbClr val="FAFAFA"/>
-                </a:solidFill>
-                <a:latin typeface="monospace" pitchFamily="34" charset="0"/>
-                <a:ea typeface="monospace" pitchFamily="34" charset="-122"/>
-                <a:cs typeface="monospace" pitchFamily="34" charset="-120"/>
-              </a:rPr>
-              <a:t>
-</a:t>
-            </a:r>
-            <a:r>
-              <a:rPr lang="en-US" sz="850" dirty="0">
-                <a:solidFill>
-                  <a:srgbClr val="FAFAFA"/>
-                </a:solidFill>
-                <a:latin typeface="monospace" pitchFamily="34" charset="0"/>
-                <a:ea typeface="monospace" pitchFamily="34" charset="-122"/>
-                <a:cs typeface="monospace" pitchFamily="34" charset="-120"/>
-              </a:rPr>
-              <a:t>git add .</a:t>
-            </a:r>
-            <a:r>
-              <a:rPr lang="en-US" sz="850" dirty="0">
-                <a:solidFill>
-                  <a:srgbClr val="FAFAFA"/>
-                </a:solidFill>
-                <a:latin typeface="monospace" pitchFamily="34" charset="0"/>
-                <a:ea typeface="monospace" pitchFamily="34" charset="-122"/>
-                <a:cs typeface="monospace" pitchFamily="34" charset="-120"/>
-              </a:rPr>
-              <a:t>
-</a:t>
-            </a:r>
-            <a:r>
-              <a:rPr lang="en-US" sz="850" dirty="0">
-                <a:solidFill>
-                  <a:srgbClr val="FAFAFA"/>
-                </a:solidFill>
-                <a:latin typeface="monospace" pitchFamily="34" charset="0"/>
-                <a:ea typeface="monospace" pitchFamily="34" charset="-122"/>
-                <a:cs typeface="monospace" pitchFamily="34" charset="-120"/>
-              </a:rPr>
-              <a:t xml:space="preserve">git commit -m "Initial ICM project </a:t>
-            </a:r>
-            <a:r>
-              <a:rPr lang="en-US" sz="850" dirty="0">
-                <a:solidFill>
-                  <a:srgbClr val="FAFAFA"/>
-                </a:solidFill>
-                <a:latin typeface="monospace" pitchFamily="34" charset="0"/>
-                <a:ea typeface="monospace" pitchFamily="34" charset="-122"/>
-                <a:cs typeface="monospace" pitchFamily="34" charset="-120"/>
-              </a:rPr>
-              <a:t>instance"</a:t>
+              <a:t>git init
+git add .
+git commit -m "Initial ICM project instance"</a:t>
             </a:r>
             <a:endParaRPr lang="en-US" sz="850" dirty="0"/>
           </a:p>
@@ -2792,7 +2423,7 @@
           <p:nvPr/>
         </p:nvPicPr>
         <p:blipFill>
-          <a:blip r:embed="rId1"/>
+          <a:blip r:embed="rId3"/>
           <a:stretch>
             <a:fillRect/>
           </a:stretch>
@@ -2830,7 +2461,7 @@
           </a:bodyPr>
           <a:lstStyle/>
           <a:p>
-            <a:pPr algn="l" indent="0" marL="0">
+            <a:pPr marL="0" indent="0" algn="l">
               <a:buNone/>
             </a:pPr>
             <a:r>
@@ -2871,7 +2502,7 @@
           </a:bodyPr>
           <a:lstStyle/>
           <a:p>
-            <a:pPr algn="l" indent="0" marL="0">
+            <a:pPr marL="0" indent="0" algn="l">
               <a:lnSpc>
                 <a:spcPct val="112000"/>
               </a:lnSpc>
@@ -2915,7 +2546,7 @@
           </a:bodyPr>
           <a:lstStyle/>
           <a:p>
-            <a:pPr algn="l" indent="0" marL="0">
+            <a:pPr marL="0" indent="0" algn="l">
               <a:buNone/>
             </a:pPr>
             <a:r>
@@ -2956,7 +2587,7 @@
           </a:bodyPr>
           <a:lstStyle/>
           <a:p>
-            <a:pPr algn="l" indent="0" marL="0">
+            <a:pPr marL="0" indent="0" algn="l">
               <a:lnSpc>
                 <a:spcPct val="112000"/>
               </a:lnSpc>
@@ -3000,7 +2631,7 @@
           </a:bodyPr>
           <a:lstStyle/>
           <a:p>
-            <a:pPr algn="l" indent="0" marL="0">
+            <a:pPr marL="0" indent="0" algn="l">
               <a:buNone/>
             </a:pPr>
             <a:r>
@@ -3041,7 +2672,7 @@
           </a:bodyPr>
           <a:lstStyle/>
           <a:p>
-            <a:pPr algn="l" indent="0" marL="0">
+            <a:pPr marL="0" indent="0" algn="l">
               <a:lnSpc>
                 <a:spcPct val="112000"/>
               </a:lnSpc>
@@ -3085,7 +2716,7 @@
           </a:bodyPr>
           <a:lstStyle/>
           <a:p>
-            <a:pPr algn="l" indent="0" marL="0">
+            <a:pPr marL="0" indent="0" algn="l">
               <a:buNone/>
             </a:pPr>
             <a:r>
@@ -3126,7 +2757,7 @@
           </a:bodyPr>
           <a:lstStyle/>
           <a:p>
-            <a:pPr algn="l" indent="0" marL="0">
+            <a:pPr marL="0" indent="0" algn="l">
               <a:lnSpc>
                 <a:spcPct val="112000"/>
               </a:lnSpc>
@@ -3170,7 +2801,7 @@
           </a:bodyPr>
           <a:lstStyle/>
           <a:p>
-            <a:pPr algn="l" indent="0" marL="0">
+            <a:pPr marL="0" indent="0" algn="l">
               <a:buNone/>
             </a:pPr>
             <a:r>
@@ -3211,7 +2842,7 @@
           </a:bodyPr>
           <a:lstStyle/>
           <a:p>
-            <a:pPr algn="l" indent="0" marL="0">
+            <a:pPr marL="0" indent="0" algn="l">
               <a:lnSpc>
                 <a:spcPct val="112000"/>
               </a:lnSpc>
@@ -3255,7 +2886,7 @@
           </a:bodyPr>
           <a:lstStyle/>
           <a:p>
-            <a:pPr algn="l" indent="0" marL="0">
+            <a:pPr marL="0" indent="0" algn="l">
               <a:buNone/>
             </a:pPr>
             <a:r>
@@ -3296,7 +2927,7 @@
           </a:bodyPr>
           <a:lstStyle/>
           <a:p>
-            <a:pPr algn="l" indent="0" marL="0">
+            <a:pPr marL="0" indent="0" algn="l">
               <a:lnSpc>
                 <a:spcPct val="112000"/>
               </a:lnSpc>
@@ -3340,7 +2971,7 @@
           </a:bodyPr>
           <a:lstStyle/>
           <a:p>
-            <a:pPr algn="l" indent="0" marL="0">
+            <a:pPr marL="0" indent="0" algn="l">
               <a:buNone/>
             </a:pPr>
             <a:r>
@@ -3381,7 +3012,7 @@
           </a:bodyPr>
           <a:lstStyle/>
           <a:p>
-            <a:pPr algn="l" indent="0" marL="0">
+            <a:pPr marL="0" indent="0" algn="l">
               <a:lnSpc>
                 <a:spcPct val="112000"/>
               </a:lnSpc>
@@ -3425,7 +3056,7 @@
           </a:bodyPr>
           <a:lstStyle/>
           <a:p>
-            <a:pPr algn="l" indent="0" marL="0">
+            <a:pPr marL="0" indent="0" algn="l">
               <a:buNone/>
             </a:pPr>
             <a:r>
@@ -3466,7 +3097,7 @@
           </a:bodyPr>
           <a:lstStyle/>
           <a:p>
-            <a:pPr algn="l" indent="0" marL="0">
+            <a:pPr marL="0" indent="0" algn="l">
               <a:lnSpc>
                 <a:spcPct val="112000"/>
               </a:lnSpc>
@@ -3510,7 +3141,7 @@
           </a:bodyPr>
           <a:lstStyle/>
           <a:p>
-            <a:pPr algn="l" indent="0" marL="0">
+            <a:pPr marL="0" indent="0" algn="l">
               <a:buNone/>
             </a:pPr>
             <a:r>
@@ -3551,7 +3182,7 @@
           </a:bodyPr>
           <a:lstStyle/>
           <a:p>
-            <a:pPr algn="l" indent="0" marL="0">
+            <a:pPr marL="0" indent="0" algn="l">
               <a:lnSpc>
                 <a:spcPct val="120000"/>
               </a:lnSpc>
@@ -3606,7 +3237,7 @@
           <p:nvPr/>
         </p:nvPicPr>
         <p:blipFill>
-          <a:blip r:embed="rId1"/>
+          <a:blip r:embed="rId3"/>
           <a:stretch>
             <a:fillRect/>
           </a:stretch>
@@ -3644,7 +3275,7 @@
           </a:bodyPr>
           <a:lstStyle/>
           <a:p>
-            <a:pPr algn="l" indent="0" marL="0">
+            <a:pPr marL="0" indent="0" algn="l">
               <a:buNone/>
             </a:pPr>
             <a:r>
@@ -3685,7 +3316,7 @@
           </a:bodyPr>
           <a:lstStyle/>
           <a:p>
-            <a:pPr algn="l" indent="0" marL="0">
+            <a:pPr marL="0" indent="0" algn="l">
               <a:lnSpc>
                 <a:spcPct val="112000"/>
               </a:lnSpc>
@@ -3729,7 +3360,7 @@
           </a:bodyPr>
           <a:lstStyle/>
           <a:p>
-            <a:pPr algn="l" indent="0" marL="0">
+            <a:pPr marL="0" indent="0" algn="l">
               <a:buNone/>
             </a:pPr>
             <a:r>
@@ -3770,13 +3401,13 @@
           </a:bodyPr>
           <a:lstStyle/>
           <a:p>
-            <a:pPr algn="l" marL="127000" indent="-127000">
+            <a:pPr marL="127000" indent="-127000" algn="l">
               <a:lnSpc>
                 <a:spcPct val="120000"/>
               </a:lnSpc>
               <a:buSzPct val="100000"/>
               <a:buFont typeface="+mj-lt"/>
-              <a:buAutoNum type="arabicPeriod" startAt="1"/>
+              <a:buAutoNum type="arabicPeriod"/>
             </a:pPr>
             <a:r>
               <a:rPr lang="en-US" sz="900" b="1" dirty="0">
@@ -3798,7 +3429,7 @@
                 <a:ea typeface="Space Grotesk" pitchFamily="34" charset="-122"/>
                 <a:cs typeface="Space Grotesk" pitchFamily="34" charset="-120"/>
               </a:rPr>
-              <a:t xml:space="preserve"> — generic-agent-oriented-ICM for general projects; systems-engineering-ICM for engineering work.</a:t>
+              <a:t> — generic-agent-oriented-ICM for general projects; systems-engineering-ICM for engineering work.</a:t>
             </a:r>
             <a:endParaRPr lang="en-US" sz="900" dirty="0"/>
           </a:p>
@@ -3827,7 +3458,7 @@
           </a:bodyPr>
           <a:lstStyle/>
           <a:p>
-            <a:pPr algn="l" marL="127000" indent="-127000">
+            <a:pPr marL="127000" indent="-127000" algn="l">
               <a:lnSpc>
                 <a:spcPct val="120000"/>
               </a:lnSpc>
@@ -3855,7 +3486,7 @@
                 <a:ea typeface="Space Grotesk" pitchFamily="34" charset="-122"/>
                 <a:cs typeface="Space Grotesk" pitchFamily="34" charset="-120"/>
               </a:rPr>
-              <a:t xml:space="preserve"> — point the AI agent at AI_PROJECT_CREATION_INSTRUCTIONS.md.</a:t>
+              <a:t> — point the AI agent at AI_PROJECT_CREATION_INSTRUCTIONS.md.</a:t>
             </a:r>
             <a:endParaRPr lang="en-US" sz="900" dirty="0"/>
           </a:p>
@@ -3884,7 +3515,7 @@
           </a:bodyPr>
           <a:lstStyle/>
           <a:p>
-            <a:pPr algn="l" marL="127000" indent="-127000">
+            <a:pPr marL="127000" indent="-127000" algn="l">
               <a:lnSpc>
                 <a:spcPct val="120000"/>
               </a:lnSpc>
@@ -3912,7 +3543,7 @@
                 <a:ea typeface="Space Grotesk" pitchFamily="34" charset="-122"/>
                 <a:cs typeface="Space Grotesk" pitchFamily="34" charset="-120"/>
               </a:rPr>
-              <a:t xml:space="preserve"> — project name, purpose, domain, technical stack, workflow stages.</a:t>
+              <a:t> — project name, purpose, domain, technical stack, workflow stages.</a:t>
             </a:r>
             <a:endParaRPr lang="en-US" sz="900" dirty="0"/>
           </a:p>
@@ -3941,7 +3572,7 @@
           </a:bodyPr>
           <a:lstStyle/>
           <a:p>
-            <a:pPr algn="l" marL="127000" indent="-127000">
+            <a:pPr marL="127000" indent="-127000" algn="l">
               <a:lnSpc>
                 <a:spcPct val="120000"/>
               </a:lnSpc>
@@ -3969,7 +3600,7 @@
                 <a:ea typeface="Space Grotesk" pitchFamily="34" charset="-122"/>
                 <a:cs typeface="Space Grotesk" pitchFamily="34" charset="-120"/>
               </a:rPr>
-              <a:t xml:space="preserve"> — verify routing is unambiguous and ownership is explicit.</a:t>
+              <a:t> — verify routing is unambiguous and ownership is explicit.</a:t>
             </a:r>
             <a:endParaRPr lang="en-US" sz="900" dirty="0"/>
           </a:p>
@@ -3998,7 +3629,7 @@
           </a:bodyPr>
           <a:lstStyle/>
           <a:p>
-            <a:pPr algn="l" marL="127000" indent="-127000">
+            <a:pPr marL="127000" indent="-127000" algn="l">
               <a:lnSpc>
                 <a:spcPct val="120000"/>
               </a:lnSpc>
@@ -4044,7 +3675,7 @@
           </a:bodyPr>
           <a:lstStyle/>
           <a:p>
-            <a:pPr algn="l" indent="0" marL="0">
+            <a:pPr marL="0" indent="0" algn="l">
               <a:lnSpc>
                 <a:spcPct val="120000"/>
               </a:lnSpc>
@@ -4073,7 +3704,7 @@
         </p:nvSpPr>
         <p:spPr>
           <a:xfrm>
-            <a:off x="2866430" y="4018359"/>
+            <a:off x="2795689" y="4032238"/>
             <a:ext cx="617237" cy="175022"/>
           </a:xfrm>
           <a:prstGeom prst="rect">
@@ -4088,7 +3719,7 @@
           </a:bodyPr>
           <a:lstStyle/>
           <a:p>
-            <a:pPr algn="l" indent="0" marL="0">
+            <a:pPr marL="0" indent="0" algn="l">
               <a:lnSpc>
                 <a:spcPct val="120000"/>
               </a:lnSpc>
@@ -4117,7 +3748,7 @@
         </p:nvSpPr>
         <p:spPr>
           <a:xfrm>
-            <a:off x="964406" y="4027289"/>
+            <a:off x="1096915" y="4200525"/>
             <a:ext cx="3539030" cy="357188"/>
           </a:xfrm>
           <a:prstGeom prst="rect">
@@ -4132,7 +3763,7 @@
           </a:bodyPr>
           <a:lstStyle/>
           <a:p>
-            <a:pPr algn="l" indent="0" marL="0">
+            <a:pPr marL="0" indent="0" algn="l">
               <a:lnSpc>
                 <a:spcPct val="120000"/>
               </a:lnSpc>
@@ -4176,7 +3807,7 @@
           </a:bodyPr>
           <a:lstStyle/>
           <a:p>
-            <a:pPr algn="l" marL="127000" indent="-127000">
+            <a:pPr marL="127000" indent="-127000" algn="l">
               <a:lnSpc>
                 <a:spcPct val="120000"/>
               </a:lnSpc>
@@ -4204,7 +3835,7 @@
                 <a:ea typeface="Space Grotesk" pitchFamily="34" charset="-122"/>
                 <a:cs typeface="Space Grotesk" pitchFamily="34" charset="-120"/>
               </a:rPr>
-              <a:t xml:space="preserve"> — point AI agents at the repository; they will self-route using context files.</a:t>
+              <a:t> — point AI agents at the repository; they will self-route using context files.</a:t>
             </a:r>
             <a:endParaRPr lang="en-US" sz="900" dirty="0"/>
           </a:p>
@@ -4233,7 +3864,7 @@
           </a:bodyPr>
           <a:lstStyle/>
           <a:p>
-            <a:pPr algn="l" indent="0" marL="0">
+            <a:pPr marL="0" indent="0" algn="l">
               <a:buNone/>
             </a:pPr>
             <a:r>
@@ -4274,7 +3905,7 @@
           </a:bodyPr>
           <a:lstStyle/>
           <a:p>
-            <a:pPr algn="l" marL="127000" indent="-127000">
+            <a:pPr marL="127000" indent="-127000" algn="l">
               <a:lnSpc>
                 <a:spcPct val="120000"/>
               </a:lnSpc>
@@ -4319,7 +3950,7 @@
           </a:bodyPr>
           <a:lstStyle/>
           <a:p>
-            <a:pPr algn="l" marL="127000" indent="-127000">
+            <a:pPr marL="127000" indent="-127000" algn="l">
               <a:lnSpc>
                 <a:spcPct val="120000"/>
               </a:lnSpc>
@@ -4364,7 +3995,7 @@
           </a:bodyPr>
           <a:lstStyle/>
           <a:p>
-            <a:pPr algn="l" marL="127000" indent="-127000">
+            <a:pPr marL="127000" indent="-127000" algn="l">
               <a:lnSpc>
                 <a:spcPct val="120000"/>
               </a:lnSpc>
@@ -4405,6 +4036,13 @@
           </a:solidFill>
           <a:ln/>
         </p:spPr>
+        <p:txBody>
+          <a:bodyPr/>
+          <a:lstStyle/>
+          <a:p>
+            <a:endParaRPr lang="en-US"/>
+          </a:p>
+        </p:txBody>
       </p:sp>
       <p:sp>
         <p:nvSpPr>
@@ -4425,6 +4063,13 @@
           </a:solidFill>
           <a:ln/>
         </p:spPr>
+        <p:txBody>
+          <a:bodyPr/>
+          <a:lstStyle/>
+          <a:p>
+            <a:endParaRPr lang="en-US"/>
+          </a:p>
+        </p:txBody>
       </p:sp>
       <p:sp>
         <p:nvSpPr>
@@ -4449,7 +4094,7 @@
           </a:bodyPr>
           <a:lstStyle/>
           <a:p>
-            <a:pPr algn="l" indent="0" marL="0">
+            <a:pPr marL="0" indent="0" algn="l">
               <a:lnSpc>
                 <a:spcPct val="120000"/>
               </a:lnSpc>
@@ -4493,7 +4138,7 @@
           </a:bodyPr>
           <a:lstStyle/>
           <a:p>
-            <a:pPr algn="l" indent="0" marL="0">
+            <a:pPr marL="0" indent="0" algn="l">
               <a:lnSpc>
                 <a:spcPct val="120000"/>
               </a:lnSpc>
@@ -4537,7 +4182,7 @@
           </a:bodyPr>
           <a:lstStyle/>
           <a:p>
-            <a:pPr algn="l" indent="0" marL="0">
+            <a:pPr marL="0" indent="0" algn="l">
               <a:lnSpc>
                 <a:spcPct val="120000"/>
               </a:lnSpc>
@@ -4581,7 +4226,7 @@
           </a:bodyPr>
           <a:lstStyle/>
           <a:p>
-            <a:pPr algn="l" indent="0" marL="0">
+            <a:pPr marL="0" indent="0" algn="l">
               <a:lnSpc>
                 <a:spcPct val="120000"/>
               </a:lnSpc>
@@ -4636,7 +4281,7 @@
           <p:nvPr/>
         </p:nvPicPr>
         <p:blipFill>
-          <a:blip r:embed="rId1"/>
+          <a:blip r:embed="rId3"/>
           <a:stretch>
             <a:fillRect/>
           </a:stretch>
@@ -4674,7 +4319,7 @@
           </a:bodyPr>
           <a:lstStyle/>
           <a:p>
-            <a:pPr algn="l" indent="0" marL="0">
+            <a:pPr marL="0" indent="0" algn="l">
               <a:buNone/>
             </a:pPr>
             <a:r>
@@ -4715,7 +4360,7 @@
           </a:bodyPr>
           <a:lstStyle/>
           <a:p>
-            <a:pPr algn="l" indent="0" marL="0">
+            <a:pPr marL="0" indent="0" algn="l">
               <a:lnSpc>
                 <a:spcPct val="112000"/>
               </a:lnSpc>
@@ -4759,7 +4404,7 @@
           </a:bodyPr>
           <a:lstStyle/>
           <a:p>
-            <a:pPr algn="l" marL="127000" indent="-127000">
+            <a:pPr marL="127000" indent="-127000" algn="l">
               <a:lnSpc>
                 <a:spcPct val="120000"/>
               </a:lnSpc>
@@ -4804,7 +4449,7 @@
           </a:bodyPr>
           <a:lstStyle/>
           <a:p>
-            <a:pPr algn="l" marL="127000" indent="-127000">
+            <a:pPr marL="127000" indent="-127000" algn="l">
               <a:lnSpc>
                 <a:spcPct val="120000"/>
               </a:lnSpc>
@@ -4849,7 +4494,7 @@
           </a:bodyPr>
           <a:lstStyle/>
           <a:p>
-            <a:pPr algn="l" marL="127000" indent="-127000">
+            <a:pPr marL="127000" indent="-127000" algn="l">
               <a:lnSpc>
                 <a:spcPct val="120000"/>
               </a:lnSpc>
@@ -4894,7 +4539,7 @@
           </a:bodyPr>
           <a:lstStyle/>
           <a:p>
-            <a:pPr algn="l" marL="127000" indent="-127000">
+            <a:pPr marL="127000" indent="-127000" algn="l">
               <a:lnSpc>
                 <a:spcPct val="120000"/>
               </a:lnSpc>
@@ -4939,7 +4584,7 @@
           </a:bodyPr>
           <a:lstStyle/>
           <a:p>
-            <a:pPr algn="l" marL="127000" indent="-127000">
+            <a:pPr marL="127000" indent="-127000" algn="l">
               <a:lnSpc>
                 <a:spcPct val="120000"/>
               </a:lnSpc>
@@ -4984,7 +4629,7 @@
           </a:bodyPr>
           <a:lstStyle/>
           <a:p>
-            <a:pPr algn="l" indent="0" marL="0">
+            <a:pPr marL="0" indent="0" algn="l">
               <a:buNone/>
             </a:pPr>
             <a:r>
@@ -5036,7 +4681,7 @@
           <p:nvPr/>
         </p:nvPicPr>
         <p:blipFill>
-          <a:blip r:embed="rId1"/>
+          <a:blip r:embed="rId3"/>
           <a:stretch>
             <a:fillRect/>
           </a:stretch>
@@ -5074,7 +4719,7 @@
           </a:bodyPr>
           <a:lstStyle/>
           <a:p>
-            <a:pPr algn="l" indent="0" marL="0">
+            <a:pPr marL="0" indent="0" algn="l">
               <a:buNone/>
             </a:pPr>
             <a:r>
@@ -5115,7 +4760,7 @@
           </a:bodyPr>
           <a:lstStyle/>
           <a:p>
-            <a:pPr algn="l" indent="0" marL="0">
+            <a:pPr marL="0" indent="0" algn="l">
               <a:lnSpc>
                 <a:spcPct val="112000"/>
               </a:lnSpc>
@@ -5159,7 +4804,7 @@
           </a:bodyPr>
           <a:lstStyle/>
           <a:p>
-            <a:pPr algn="l" indent="0" marL="0">
+            <a:pPr marL="0" indent="0" algn="l">
               <a:buNone/>
             </a:pPr>
             <a:r>
@@ -5200,7 +4845,7 @@
           </a:bodyPr>
           <a:lstStyle/>
           <a:p>
-            <a:pPr algn="l" indent="0" marL="0">
+            <a:pPr marL="0" indent="0" algn="l">
               <a:lnSpc>
                 <a:spcPct val="120000"/>
               </a:lnSpc>
@@ -5244,7 +4889,7 @@
           </a:bodyPr>
           <a:lstStyle/>
           <a:p>
-            <a:pPr algn="l" marL="127000" indent="-127000">
+            <a:pPr marL="127000" indent="-127000" algn="l">
               <a:lnSpc>
                 <a:spcPct val="120000"/>
               </a:lnSpc>
@@ -5289,7 +4934,7 @@
           </a:bodyPr>
           <a:lstStyle/>
           <a:p>
-            <a:pPr algn="l" marL="127000" indent="-127000">
+            <a:pPr marL="127000" indent="-127000" algn="l">
               <a:lnSpc>
                 <a:spcPct val="120000"/>
               </a:lnSpc>
@@ -5334,7 +4979,7 @@
           </a:bodyPr>
           <a:lstStyle/>
           <a:p>
-            <a:pPr algn="l" marL="127000" indent="-127000">
+            <a:pPr marL="127000" indent="-127000" algn="l">
               <a:lnSpc>
                 <a:spcPct val="120000"/>
               </a:lnSpc>
@@ -5379,7 +5024,7 @@
           </a:bodyPr>
           <a:lstStyle/>
           <a:p>
-            <a:pPr algn="l" indent="0" marL="0">
+            <a:pPr marL="0" indent="0" algn="l">
               <a:buNone/>
             </a:pPr>
             <a:r>
@@ -5420,7 +5065,7 @@
           </a:bodyPr>
           <a:lstStyle/>
           <a:p>
-            <a:pPr algn="l" indent="0" marL="0">
+            <a:pPr marL="0" indent="0" algn="l">
               <a:lnSpc>
                 <a:spcPct val="120000"/>
               </a:lnSpc>
@@ -5435,7 +5080,7 @@
                 <a:ea typeface="Space Grotesk" pitchFamily="34" charset="-122"/>
                 <a:cs typeface="Space Grotesk" pitchFamily="34" charset="-120"/>
               </a:rPr>
-              <a:t xml:space="preserve">The folder structure itself </a:t>
+              <a:t>The folder structure itself </a:t>
             </a:r>
             <a:r>
               <a:rPr lang="en-US" sz="850" i="1" dirty="0">
@@ -5457,40 +5102,7 @@
                 <a:ea typeface="Space Grotesk" pitchFamily="34" charset="-122"/>
                 <a:cs typeface="Space Grotesk" pitchFamily="34" charset="-120"/>
               </a:rPr>
-              <a:t xml:space="preserve"> the workflow </a:t>
-            </a:r>
-            <a:r>
-              <a:rPr lang="en-US" sz="850" dirty="0">
-                <a:solidFill>
-                  <a:srgbClr val="333333"/>
-                </a:solidFill>
-                <a:latin typeface="Space Grotesk" pitchFamily="34" charset="0"/>
-                <a:ea typeface="Space Grotesk" pitchFamily="34" charset="-122"/>
-                <a:cs typeface="Space Grotesk" pitchFamily="34" charset="-120"/>
-              </a:rPr>
-              <a:t xml:space="preserve">engine: folder names, file names, and file </a:t>
-            </a:r>
-            <a:r>
-              <a:rPr lang="en-US" sz="850" dirty="0">
-                <a:solidFill>
-                  <a:srgbClr val="333333"/>
-                </a:solidFill>
-                <a:latin typeface="Space Grotesk" pitchFamily="34" charset="0"/>
-                <a:ea typeface="Space Grotesk" pitchFamily="34" charset="-122"/>
-                <a:cs typeface="Space Grotesk" pitchFamily="34" charset="-120"/>
-              </a:rPr>
-              <a:t xml:space="preserve">contents collectively define what the </a:t>
-            </a:r>
-            <a:r>
-              <a:rPr lang="en-US" sz="850" dirty="0">
-                <a:solidFill>
-                  <a:srgbClr val="333333"/>
-                </a:solidFill>
-                <a:latin typeface="Space Grotesk" pitchFamily="34" charset="0"/>
-                <a:ea typeface="Space Grotesk" pitchFamily="34" charset="-122"/>
-                <a:cs typeface="Space Grotesk" pitchFamily="34" charset="-120"/>
-              </a:rPr>
-              <a:t>agent should do and where.</a:t>
+              <a:t> the workflow engine: folder names, file names, and file contents collectively define what the agent should do and where.</a:t>
             </a:r>
             <a:endParaRPr lang="en-US" sz="850" dirty="0"/>
           </a:p>
@@ -5519,7 +5131,7 @@
           </a:bodyPr>
           <a:lstStyle/>
           <a:p>
-            <a:pPr algn="l" marL="127000" indent="-127000">
+            <a:pPr marL="127000" indent="-127000" algn="l">
               <a:lnSpc>
                 <a:spcPct val="120000"/>
               </a:lnSpc>
@@ -5564,7 +5176,7 @@
           </a:bodyPr>
           <a:lstStyle/>
           <a:p>
-            <a:pPr algn="l" marL="127000" indent="-127000">
+            <a:pPr marL="127000" indent="-127000" algn="l">
               <a:lnSpc>
                 <a:spcPct val="120000"/>
               </a:lnSpc>
@@ -5609,7 +5221,7 @@
           </a:bodyPr>
           <a:lstStyle/>
           <a:p>
-            <a:pPr algn="l" indent="0" marL="0">
+            <a:pPr marL="0" indent="0" algn="l">
               <a:buNone/>
             </a:pPr>
             <a:r>
@@ -5650,7 +5262,7 @@
           </a:bodyPr>
           <a:lstStyle/>
           <a:p>
-            <a:pPr algn="l" indent="0" marL="0">
+            <a:pPr marL="0" indent="0" algn="l">
               <a:lnSpc>
                 <a:spcPct val="120000"/>
               </a:lnSpc>
@@ -5705,7 +5317,7 @@
           <p:nvPr/>
         </p:nvPicPr>
         <p:blipFill>
-          <a:blip r:embed="rId1"/>
+          <a:blip r:embed="rId3"/>
           <a:stretch>
             <a:fillRect/>
           </a:stretch>
@@ -5743,7 +5355,7 @@
           </a:bodyPr>
           <a:lstStyle/>
           <a:p>
-            <a:pPr algn="l" indent="0" marL="0">
+            <a:pPr marL="0" indent="0" algn="l">
               <a:buNone/>
             </a:pPr>
             <a:r>
@@ -5784,7 +5396,7 @@
           </a:bodyPr>
           <a:lstStyle/>
           <a:p>
-            <a:pPr algn="l" indent="0" marL="0">
+            <a:pPr marL="0" indent="0" algn="l">
               <a:lnSpc>
                 <a:spcPct val="112000"/>
               </a:lnSpc>
@@ -5828,7 +5440,7 @@
           </a:bodyPr>
           <a:lstStyle/>
           <a:p>
-            <a:pPr algn="l" indent="0" marL="0">
+            <a:pPr marL="0" indent="0" algn="l">
               <a:buNone/>
             </a:pPr>
             <a:r>
@@ -5869,7 +5481,7 @@
           </a:bodyPr>
           <a:lstStyle/>
           <a:p>
-            <a:pPr algn="l" indent="0" marL="0">
+            <a:pPr marL="0" indent="0" algn="l">
               <a:lnSpc>
                 <a:spcPct val="112000"/>
               </a:lnSpc>
@@ -5913,7 +5525,7 @@
           </a:bodyPr>
           <a:lstStyle/>
           <a:p>
-            <a:pPr algn="l" indent="0" marL="0">
+            <a:pPr marL="0" indent="0" algn="l">
               <a:buNone/>
             </a:pPr>
             <a:r>
@@ -5954,7 +5566,7 @@
           </a:bodyPr>
           <a:lstStyle/>
           <a:p>
-            <a:pPr algn="l" indent="0" marL="0">
+            <a:pPr marL="0" indent="0" algn="l">
               <a:lnSpc>
                 <a:spcPct val="112000"/>
               </a:lnSpc>
@@ -5998,7 +5610,7 @@
           </a:bodyPr>
           <a:lstStyle/>
           <a:p>
-            <a:pPr algn="l" indent="0" marL="0">
+            <a:pPr marL="0" indent="0" algn="l">
               <a:buNone/>
             </a:pPr>
             <a:r>
@@ -6039,7 +5651,7 @@
           </a:bodyPr>
           <a:lstStyle/>
           <a:p>
-            <a:pPr algn="l" indent="0" marL="0">
+            <a:pPr marL="0" indent="0" algn="l">
               <a:lnSpc>
                 <a:spcPct val="112000"/>
               </a:lnSpc>
@@ -6083,7 +5695,7 @@
           </a:bodyPr>
           <a:lstStyle/>
           <a:p>
-            <a:pPr algn="l" indent="0" marL="0">
+            <a:pPr marL="0" indent="0" algn="l">
               <a:buNone/>
             </a:pPr>
             <a:r>
@@ -6124,7 +5736,7 @@
           </a:bodyPr>
           <a:lstStyle/>
           <a:p>
-            <a:pPr algn="l" indent="0" marL="0">
+            <a:pPr marL="0" indent="0" algn="l">
               <a:lnSpc>
                 <a:spcPct val="112000"/>
               </a:lnSpc>
@@ -6168,7 +5780,7 @@
           </a:bodyPr>
           <a:lstStyle/>
           <a:p>
-            <a:pPr algn="l" indent="0" marL="0">
+            <a:pPr marL="0" indent="0" algn="l">
               <a:buNone/>
             </a:pPr>
             <a:r>
@@ -6209,7 +5821,7 @@
           </a:bodyPr>
           <a:lstStyle/>
           <a:p>
-            <a:pPr algn="l" indent="0" marL="0">
+            <a:pPr marL="0" indent="0" algn="l">
               <a:lnSpc>
                 <a:spcPct val="112000"/>
               </a:lnSpc>
@@ -6253,7 +5865,7 @@
           </a:bodyPr>
           <a:lstStyle/>
           <a:p>
-            <a:pPr algn="l" indent="0" marL="0">
+            <a:pPr marL="0" indent="0" algn="l">
               <a:buNone/>
             </a:pPr>
             <a:r>
@@ -6305,7 +5917,7 @@
           <p:nvPr/>
         </p:nvPicPr>
         <p:blipFill>
-          <a:blip r:embed="rId1"/>
+          <a:blip r:embed="rId3"/>
           <a:stretch>
             <a:fillRect/>
           </a:stretch>
@@ -6343,7 +5955,7 @@
           </a:bodyPr>
           <a:lstStyle/>
           <a:p>
-            <a:pPr algn="l" indent="0" marL="0">
+            <a:pPr marL="0" indent="0" algn="l">
               <a:buNone/>
             </a:pPr>
             <a:r>
@@ -6384,7 +5996,7 @@
           </a:bodyPr>
           <a:lstStyle/>
           <a:p>
-            <a:pPr algn="l" indent="0" marL="0">
+            <a:pPr marL="0" indent="0" algn="l">
               <a:lnSpc>
                 <a:spcPct val="112000"/>
               </a:lnSpc>
@@ -6428,7 +6040,7 @@
           </a:bodyPr>
           <a:lstStyle/>
           <a:p>
-            <a:pPr algn="l" indent="0" marL="0">
+            <a:pPr marL="0" indent="0" algn="l">
               <a:buNone/>
             </a:pPr>
             <a:r>
@@ -6469,7 +6081,7 @@
           </a:bodyPr>
           <a:lstStyle/>
           <a:p>
-            <a:pPr algn="l" indent="0" marL="0">
+            <a:pPr marL="0" indent="0" algn="l">
               <a:buNone/>
             </a:pPr>
             <a:r>
@@ -6510,7 +6122,7 @@
           </a:bodyPr>
           <a:lstStyle/>
           <a:p>
-            <a:pPr algn="l" marL="127000" indent="-127000">
+            <a:pPr marL="127000" indent="-127000" algn="l">
               <a:lnSpc>
                 <a:spcPct val="120000"/>
               </a:lnSpc>
@@ -6555,7 +6167,7 @@
           </a:bodyPr>
           <a:lstStyle/>
           <a:p>
-            <a:pPr algn="l" marL="127000" indent="-127000">
+            <a:pPr marL="127000" indent="-127000" algn="l">
               <a:lnSpc>
                 <a:spcPct val="120000"/>
               </a:lnSpc>
@@ -6600,7 +6212,7 @@
           </a:bodyPr>
           <a:lstStyle/>
           <a:p>
-            <a:pPr algn="l" marL="127000" indent="-127000">
+            <a:pPr marL="127000" indent="-127000" algn="l">
               <a:lnSpc>
                 <a:spcPct val="120000"/>
               </a:lnSpc>
@@ -6645,7 +6257,7 @@
           </a:bodyPr>
           <a:lstStyle/>
           <a:p>
-            <a:pPr algn="l" marL="127000" indent="-127000">
+            <a:pPr marL="127000" indent="-127000" algn="l">
               <a:lnSpc>
                 <a:spcPct val="120000"/>
               </a:lnSpc>
@@ -6690,7 +6302,7 @@
           </a:bodyPr>
           <a:lstStyle/>
           <a:p>
-            <a:pPr algn="l" indent="0" marL="0">
+            <a:pPr marL="0" indent="0" algn="l">
               <a:buNone/>
             </a:pPr>
             <a:r>
@@ -6731,7 +6343,7 @@
           </a:bodyPr>
           <a:lstStyle/>
           <a:p>
-            <a:pPr algn="l" indent="0" marL="0">
+            <a:pPr marL="0" indent="0" algn="l">
               <a:buNone/>
             </a:pPr>
             <a:r>
@@ -6772,7 +6384,7 @@
           </a:bodyPr>
           <a:lstStyle/>
           <a:p>
-            <a:pPr algn="l" marL="127000" indent="-127000">
+            <a:pPr marL="127000" indent="-127000" algn="l">
               <a:lnSpc>
                 <a:spcPct val="120000"/>
               </a:lnSpc>
@@ -6817,7 +6429,7 @@
           </a:bodyPr>
           <a:lstStyle/>
           <a:p>
-            <a:pPr algn="l" marL="127000" indent="-127000">
+            <a:pPr marL="127000" indent="-127000" algn="l">
               <a:lnSpc>
                 <a:spcPct val="120000"/>
               </a:lnSpc>
@@ -6862,7 +6474,7 @@
           </a:bodyPr>
           <a:lstStyle/>
           <a:p>
-            <a:pPr algn="l" marL="127000" indent="-127000">
+            <a:pPr marL="127000" indent="-127000" algn="l">
               <a:lnSpc>
                 <a:spcPct val="120000"/>
               </a:lnSpc>
@@ -6907,7 +6519,7 @@
           </a:bodyPr>
           <a:lstStyle/>
           <a:p>
-            <a:pPr algn="l" indent="0" marL="0">
+            <a:pPr marL="0" indent="0" algn="l">
               <a:buNone/>
             </a:pPr>
             <a:r>
@@ -6948,7 +6560,7 @@
           </a:bodyPr>
           <a:lstStyle/>
           <a:p>
-            <a:pPr algn="l" indent="0" marL="0">
+            <a:pPr marL="0" indent="0" algn="l">
               <a:buNone/>
             </a:pPr>
             <a:r>
@@ -6989,7 +6601,7 @@
           </a:bodyPr>
           <a:lstStyle/>
           <a:p>
-            <a:pPr algn="l" marL="127000" indent="-127000">
+            <a:pPr marL="127000" indent="-127000" algn="l">
               <a:lnSpc>
                 <a:spcPct val="120000"/>
               </a:lnSpc>
@@ -7034,7 +6646,7 @@
           </a:bodyPr>
           <a:lstStyle/>
           <a:p>
-            <a:pPr algn="l" marL="127000" indent="-127000">
+            <a:pPr marL="127000" indent="-127000" algn="l">
               <a:lnSpc>
                 <a:spcPct val="120000"/>
               </a:lnSpc>
@@ -7079,7 +6691,7 @@
           </a:bodyPr>
           <a:lstStyle/>
           <a:p>
-            <a:pPr algn="l" marL="127000" indent="-127000">
+            <a:pPr marL="127000" indent="-127000" algn="l">
               <a:lnSpc>
                 <a:spcPct val="120000"/>
               </a:lnSpc>
@@ -7135,7 +6747,7 @@
           <p:nvPr/>
         </p:nvPicPr>
         <p:blipFill>
-          <a:blip r:embed="rId1"/>
+          <a:blip r:embed="rId3"/>
           <a:stretch>
             <a:fillRect/>
           </a:stretch>
@@ -7173,7 +6785,7 @@
           </a:bodyPr>
           <a:lstStyle/>
           <a:p>
-            <a:pPr algn="l" indent="0" marL="0">
+            <a:pPr marL="0" indent="0" algn="l">
               <a:buNone/>
             </a:pPr>
             <a:r>
@@ -7214,7 +6826,7 @@
           </a:bodyPr>
           <a:lstStyle/>
           <a:p>
-            <a:pPr algn="l" indent="0" marL="0">
+            <a:pPr marL="0" indent="0" algn="l">
               <a:buNone/>
             </a:pPr>
             <a:r>
@@ -7255,7 +6867,7 @@
           </a:bodyPr>
           <a:lstStyle/>
           <a:p>
-            <a:pPr algn="l" indent="0" marL="0">
+            <a:pPr marL="0" indent="0" algn="l">
               <a:buNone/>
             </a:pPr>
             <a:r>
@@ -7296,7 +6908,7 @@
           </a:bodyPr>
           <a:lstStyle/>
           <a:p>
-            <a:pPr algn="l" indent="0" marL="0">
+            <a:pPr marL="0" indent="0" algn="l">
               <a:lnSpc>
                 <a:spcPct val="120000"/>
               </a:lnSpc>
@@ -7340,7 +6952,7 @@
           </a:bodyPr>
           <a:lstStyle/>
           <a:p>
-            <a:pPr algn="l" indent="0" marL="0">
+            <a:pPr marL="0" indent="0" algn="l">
               <a:buNone/>
             </a:pPr>
             <a:r>
@@ -7381,7 +6993,7 @@
           </a:bodyPr>
           <a:lstStyle/>
           <a:p>
-            <a:pPr algn="l" indent="0" marL="0">
+            <a:pPr marL="0" indent="0" algn="l">
               <a:lnSpc>
                 <a:spcPct val="112000"/>
               </a:lnSpc>
@@ -7408,18 +7020,7 @@
                 <a:cs typeface="Space Grotesk" pitchFamily="34" charset="-120"/>
               </a:rPr>
               <a:t>
-</a:t>
-            </a:r>
-            <a:r>
-              <a:rPr lang="en-US" sz="850" dirty="0">
-                <a:solidFill>
-                  <a:srgbClr val="333333"/>
-                </a:solidFill>
-                <a:latin typeface="Space Grotesk" pitchFamily="34" charset="0"/>
-                <a:ea typeface="Space Grotesk" pitchFamily="34" charset="-122"/>
-                <a:cs typeface="Space Grotesk" pitchFamily="34" charset="-120"/>
-              </a:rPr>
-              <a:t>Tutorials, documentation, content</a:t>
+Tutorials, documentation, content</a:t>
             </a:r>
             <a:endParaRPr lang="en-US" sz="800" dirty="0"/>
           </a:p>
@@ -7448,7 +7049,7 @@
           </a:bodyPr>
           <a:lstStyle/>
           <a:p>
-            <a:pPr algn="l" indent="0" marL="0">
+            <a:pPr marL="0" indent="0" algn="l">
               <a:lnSpc>
                 <a:spcPct val="112000"/>
               </a:lnSpc>
@@ -7475,18 +7076,7 @@
                 <a:cs typeface="Space Grotesk" pitchFamily="34" charset="-120"/>
               </a:rPr>
               <a:t>
-</a:t>
-            </a:r>
-            <a:r>
-              <a:rPr lang="en-US" sz="850" dirty="0">
-                <a:solidFill>
-                  <a:srgbClr val="333333"/>
-                </a:solidFill>
-                <a:latin typeface="Space Grotesk" pitchFamily="34" charset="0"/>
-                <a:ea typeface="Space Grotesk" pitchFamily="34" charset="-122"/>
-                <a:cs typeface="Space Grotesk" pitchFamily="34" charset="-120"/>
-              </a:rPr>
-              <a:t>Implementation, software builds, engineering</a:t>
+Implementation, software builds, engineering</a:t>
             </a:r>
             <a:endParaRPr lang="en-US" sz="800" dirty="0"/>
           </a:p>
@@ -7515,7 +7105,7 @@
           </a:bodyPr>
           <a:lstStyle/>
           <a:p>
-            <a:pPr algn="l" indent="0" marL="0">
+            <a:pPr marL="0" indent="0" algn="l">
               <a:lnSpc>
                 <a:spcPct val="112000"/>
               </a:lnSpc>
@@ -7542,18 +7132,7 @@
                 <a:cs typeface="Space Grotesk" pitchFamily="34" charset="-120"/>
               </a:rPr>
               <a:t>
-</a:t>
-            </a:r>
-            <a:r>
-              <a:rPr lang="en-US" sz="850" dirty="0">
-                <a:solidFill>
-                  <a:srgbClr val="333333"/>
-                </a:solidFill>
-                <a:latin typeface="Space Grotesk" pitchFamily="34" charset="0"/>
-                <a:ea typeface="Space Grotesk" pitchFamily="34" charset="-122"/>
-                <a:cs typeface="Space Grotesk" pitchFamily="34" charset="-120"/>
-              </a:rPr>
-              <a:t>Outreach, marketing, customer communication</a:t>
+Outreach, marketing, customer communication</a:t>
             </a:r>
             <a:endParaRPr lang="en-US" sz="800" dirty="0"/>
           </a:p>
@@ -7582,7 +7161,7 @@
           </a:bodyPr>
           <a:lstStyle/>
           <a:p>
-            <a:pPr algn="l" indent="0" marL="0">
+            <a:pPr marL="0" indent="0" algn="l">
               <a:buNone/>
             </a:pPr>
             <a:r>
@@ -7623,7 +7202,7 @@
           </a:bodyPr>
           <a:lstStyle/>
           <a:p>
-            <a:pPr algn="l" indent="0" marL="0">
+            <a:pPr marL="0" indent="0" algn="l">
               <a:lnSpc>
                 <a:spcPct val="120000"/>
               </a:lnSpc>
@@ -7667,7 +7246,7 @@
           </a:bodyPr>
           <a:lstStyle/>
           <a:p>
-            <a:pPr algn="l" indent="0" marL="0">
+            <a:pPr marL="0" indent="0" algn="l">
               <a:buNone/>
             </a:pPr>
             <a:r>
@@ -7708,7 +7287,7 @@
           </a:bodyPr>
           <a:lstStyle/>
           <a:p>
-            <a:pPr algn="l" indent="0" marL="0">
+            <a:pPr marL="0" indent="0" algn="l">
               <a:lnSpc>
                 <a:spcPct val="112000"/>
               </a:lnSpc>
@@ -7735,18 +7314,7 @@
                 <a:cs typeface="Space Grotesk" pitchFamily="34" charset="-120"/>
               </a:rPr>
               <a:t>
-</a:t>
-            </a:r>
-            <a:r>
-              <a:rPr lang="en-US" sz="850" dirty="0">
-                <a:solidFill>
-                  <a:srgbClr val="333333"/>
-                </a:solidFill>
-                <a:latin typeface="Space Grotesk" pitchFamily="34" charset="0"/>
-                <a:ea typeface="Space Grotesk" pitchFamily="34" charset="-122"/>
-                <a:cs typeface="Space Grotesk" pitchFamily="34" charset="-120"/>
-              </a:rPr>
-              <a:t>Software, automation, instrumentation</a:t>
+Software, automation, instrumentation</a:t>
             </a:r>
             <a:endParaRPr lang="en-US" sz="800" dirty="0"/>
           </a:p>
@@ -7775,7 +7343,7 @@
           </a:bodyPr>
           <a:lstStyle/>
           <a:p>
-            <a:pPr algn="l" indent="0" marL="0">
+            <a:pPr marL="0" indent="0" algn="l">
               <a:lnSpc>
                 <a:spcPct val="112000"/>
               </a:lnSpc>
@@ -7802,18 +7370,7 @@
                 <a:cs typeface="Space Grotesk" pitchFamily="34" charset="-120"/>
               </a:rPr>
               <a:t>
-</a:t>
-            </a:r>
-            <a:r>
-              <a:rPr lang="en-US" sz="850" dirty="0">
-                <a:solidFill>
-                  <a:srgbClr val="333333"/>
-                </a:solidFill>
-                <a:latin typeface="Space Grotesk" pitchFamily="34" charset="0"/>
-                <a:ea typeface="Space Grotesk" pitchFamily="34" charset="-122"/>
-                <a:cs typeface="Space Grotesk" pitchFamily="34" charset="-120"/>
-              </a:rPr>
-              <a:t>Manuals, plans, validation docs</a:t>
+Manuals, plans, validation docs</a:t>
             </a:r>
             <a:endParaRPr lang="en-US" sz="800" dirty="0"/>
           </a:p>
@@ -7842,7 +7399,7 @@
           </a:bodyPr>
           <a:lstStyle/>
           <a:p>
-            <a:pPr algn="l" indent="0" marL="0">
+            <a:pPr marL="0" indent="0" algn="l">
               <a:lnSpc>
                 <a:spcPct val="112000"/>
               </a:lnSpc>
@@ -7869,18 +7426,7 @@
                 <a:cs typeface="Space Grotesk" pitchFamily="34" charset="-120"/>
               </a:rPr>
               <a:t>
-</a:t>
-            </a:r>
-            <a:r>
-              <a:rPr lang="en-US" sz="850" dirty="0">
-                <a:solidFill>
-                  <a:srgbClr val="333333"/>
-                </a:solidFill>
-                <a:latin typeface="Space Grotesk" pitchFamily="34" charset="0"/>
-                <a:ea typeface="Space Grotesk" pitchFamily="34" charset="-122"/>
-                <a:cs typeface="Space Grotesk" pitchFamily="34" charset="-120"/>
-              </a:rPr>
-              <a:t>Proposals, technical collateral, presentations</a:t>
+Proposals, technical collateral, presentations</a:t>
             </a:r>
             <a:endParaRPr lang="en-US" sz="800" dirty="0"/>
           </a:p>
@@ -7909,7 +7455,7 @@
           </a:bodyPr>
           <a:lstStyle/>
           <a:p>
-            <a:pPr algn="l" indent="0" marL="0">
+            <a:pPr marL="0" indent="0" algn="l">
               <a:buNone/>
             </a:pPr>
             <a:r>
@@ -7950,7 +7496,7 @@
           </a:bodyPr>
           <a:lstStyle/>
           <a:p>
-            <a:pPr algn="l" indent="0" marL="0">
+            <a:pPr marL="0" indent="0" algn="l">
               <a:lnSpc>
                 <a:spcPct val="120000"/>
               </a:lnSpc>
@@ -8005,7 +7551,7 @@
           <p:nvPr/>
         </p:nvPicPr>
         <p:blipFill>
-          <a:blip r:embed="rId1"/>
+          <a:blip r:embed="rId3"/>
           <a:stretch>
             <a:fillRect/>
           </a:stretch>
@@ -8043,7 +7589,7 @@
           </a:bodyPr>
           <a:lstStyle/>
           <a:p>
-            <a:pPr algn="l" indent="0" marL="0">
+            <a:pPr marL="0" indent="0" algn="l">
               <a:buNone/>
             </a:pPr>
             <a:r>
@@ -8084,7 +7630,7 @@
           </a:bodyPr>
           <a:lstStyle/>
           <a:p>
-            <a:pPr algn="l" indent="0" marL="0">
+            <a:pPr marL="0" indent="0" algn="l">
               <a:lnSpc>
                 <a:spcPct val="112000"/>
               </a:lnSpc>
@@ -8128,7 +7674,7 @@
           </a:bodyPr>
           <a:lstStyle/>
           <a:p>
-            <a:pPr algn="l" indent="0" marL="0">
+            <a:pPr marL="0" indent="0" algn="l">
               <a:buNone/>
             </a:pPr>
             <a:r>
@@ -8169,7 +7715,7 @@
           </a:bodyPr>
           <a:lstStyle/>
           <a:p>
-            <a:pPr algn="l" indent="0" marL="0">
+            <a:pPr marL="0" indent="0" algn="l">
               <a:buNone/>
             </a:pPr>
             <a:r>
@@ -8210,7 +7756,7 @@
           </a:bodyPr>
           <a:lstStyle/>
           <a:p>
-            <a:pPr algn="l" indent="0" marL="0">
+            <a:pPr marL="0" indent="0" algn="l">
               <a:lnSpc>
                 <a:spcPct val="112000"/>
               </a:lnSpc>
@@ -8254,7 +7800,7 @@
           </a:bodyPr>
           <a:lstStyle/>
           <a:p>
-            <a:pPr algn="l" indent="0" marL="0">
+            <a:pPr marL="0" indent="0" algn="l">
               <a:lnSpc>
                 <a:spcPct val="112000"/>
               </a:lnSpc>
@@ -8298,7 +7844,7 @@
           </a:bodyPr>
           <a:lstStyle/>
           <a:p>
-            <a:pPr algn="l" indent="0" marL="0">
+            <a:pPr marL="0" indent="0" algn="l">
               <a:lnSpc>
                 <a:spcPct val="112000"/>
               </a:lnSpc>
@@ -8342,7 +7888,7 @@
           </a:bodyPr>
           <a:lstStyle/>
           <a:p>
-            <a:pPr algn="l" indent="0" marL="0">
+            <a:pPr marL="0" indent="0" algn="l">
               <a:lnSpc>
                 <a:spcPct val="112000"/>
               </a:lnSpc>
@@ -8386,7 +7932,7 @@
           </a:bodyPr>
           <a:lstStyle/>
           <a:p>
-            <a:pPr algn="l" indent="0" marL="0">
+            <a:pPr marL="0" indent="0" algn="l">
               <a:buNone/>
             </a:pPr>
             <a:r>
@@ -8427,7 +7973,7 @@
           </a:bodyPr>
           <a:lstStyle/>
           <a:p>
-            <a:pPr algn="l" indent="0" marL="0">
+            <a:pPr marL="0" indent="0" algn="l">
               <a:buNone/>
             </a:pPr>
             <a:r>
@@ -8468,7 +8014,7 @@
           </a:bodyPr>
           <a:lstStyle/>
           <a:p>
-            <a:pPr algn="l" indent="0" marL="0">
+            <a:pPr marL="0" indent="0" algn="l">
               <a:lnSpc>
                 <a:spcPct val="112000"/>
               </a:lnSpc>
@@ -8512,7 +8058,7 @@
           </a:bodyPr>
           <a:lstStyle/>
           <a:p>
-            <a:pPr algn="l" indent="0" marL="0">
+            <a:pPr marL="0" indent="0" algn="l">
               <a:lnSpc>
                 <a:spcPct val="112000"/>
               </a:lnSpc>
@@ -8556,7 +8102,7 @@
           </a:bodyPr>
           <a:lstStyle/>
           <a:p>
-            <a:pPr algn="l" indent="0" marL="0">
+            <a:pPr marL="0" indent="0" algn="l">
               <a:lnSpc>
                 <a:spcPct val="112000"/>
               </a:lnSpc>
@@ -8600,7 +8146,7 @@
           </a:bodyPr>
           <a:lstStyle/>
           <a:p>
-            <a:pPr algn="l" indent="0" marL="0">
+            <a:pPr marL="0" indent="0" algn="l">
               <a:lnSpc>
                 <a:spcPct val="112000"/>
               </a:lnSpc>
@@ -8644,7 +8190,7 @@
           </a:bodyPr>
           <a:lstStyle/>
           <a:p>
-            <a:pPr algn="l" indent="0" marL="0">
+            <a:pPr marL="0" indent="0" algn="l">
               <a:buNone/>
             </a:pPr>
             <a:r>
@@ -8685,7 +8231,7 @@
           </a:bodyPr>
           <a:lstStyle/>
           <a:p>
-            <a:pPr algn="l" indent="0" marL="0">
+            <a:pPr marL="0" indent="0" algn="l">
               <a:buNone/>
             </a:pPr>
             <a:r>
@@ -8726,7 +8272,7 @@
           </a:bodyPr>
           <a:lstStyle/>
           <a:p>
-            <a:pPr algn="l" indent="0" marL="0">
+            <a:pPr marL="0" indent="0" algn="l">
               <a:lnSpc>
                 <a:spcPct val="112000"/>
               </a:lnSpc>
@@ -8770,7 +8316,7 @@
           </a:bodyPr>
           <a:lstStyle/>
           <a:p>
-            <a:pPr algn="l" indent="0" marL="0">
+            <a:pPr marL="0" indent="0" algn="l">
               <a:buNone/>
             </a:pPr>
             <a:r>
@@ -8811,7 +8357,7 @@
           </a:bodyPr>
           <a:lstStyle/>
           <a:p>
-            <a:pPr algn="l" indent="0" marL="0">
+            <a:pPr marL="0" indent="0" algn="l">
               <a:buNone/>
             </a:pPr>
             <a:r>
@@ -8852,7 +8398,7 @@
           </a:bodyPr>
           <a:lstStyle/>
           <a:p>
-            <a:pPr algn="l" indent="0" marL="0">
+            <a:pPr marL="0" indent="0" algn="l">
               <a:lnSpc>
                 <a:spcPct val="112000"/>
               </a:lnSpc>
@@ -8896,7 +8442,7 @@
           </a:bodyPr>
           <a:lstStyle/>
           <a:p>
-            <a:pPr algn="l" indent="0" marL="0">
+            <a:pPr marL="0" indent="0" algn="l">
               <a:lnSpc>
                 <a:spcPct val="112000"/>
               </a:lnSpc>
@@ -8940,7 +8486,7 @@
           </a:bodyPr>
           <a:lstStyle/>
           <a:p>
-            <a:pPr algn="l" indent="0" marL="0">
+            <a:pPr marL="0" indent="0" algn="l">
               <a:lnSpc>
                 <a:spcPct val="112000"/>
               </a:lnSpc>
@@ -8984,7 +8530,7 @@
           </a:bodyPr>
           <a:lstStyle/>
           <a:p>
-            <a:pPr algn="l" indent="0" marL="0">
+            <a:pPr marL="0" indent="0" algn="l">
               <a:lnSpc>
                 <a:spcPct val="112000"/>
               </a:lnSpc>
@@ -9028,7 +8574,7 @@
           </a:bodyPr>
           <a:lstStyle/>
           <a:p>
-            <a:pPr algn="l" indent="0" marL="0">
+            <a:pPr marL="0" indent="0" algn="l">
               <a:lnSpc>
                 <a:spcPct val="112000"/>
               </a:lnSpc>
@@ -9072,7 +8618,7 @@
           </a:bodyPr>
           <a:lstStyle/>
           <a:p>
-            <a:pPr algn="l" indent="0" marL="0">
+            <a:pPr marL="0" indent="0" algn="l">
               <a:lnSpc>
                 <a:spcPct val="112000"/>
               </a:lnSpc>
@@ -9116,7 +8662,7 @@
           </a:bodyPr>
           <a:lstStyle/>
           <a:p>
-            <a:pPr algn="l" indent="0" marL="0">
+            <a:pPr marL="0" indent="0" algn="l">
               <a:lnSpc>
                 <a:spcPct val="112000"/>
               </a:lnSpc>
@@ -9160,7 +8706,7 @@
           </a:bodyPr>
           <a:lstStyle/>
           <a:p>
-            <a:pPr algn="l" indent="0" marL="0">
+            <a:pPr marL="0" indent="0" algn="l">
               <a:buNone/>
             </a:pPr>
             <a:r>
@@ -9201,7 +8747,7 @@
           </a:bodyPr>
           <a:lstStyle/>
           <a:p>
-            <a:pPr algn="l" indent="0" marL="0">
+            <a:pPr marL="0" indent="0" algn="l">
               <a:buNone/>
             </a:pPr>
             <a:r>
@@ -9242,7 +8788,7 @@
           </a:bodyPr>
           <a:lstStyle/>
           <a:p>
-            <a:pPr algn="l" indent="0" marL="0">
+            <a:pPr marL="0" indent="0" algn="l">
               <a:lnSpc>
                 <a:spcPct val="112000"/>
               </a:lnSpc>
@@ -9286,7 +8832,7 @@
           </a:bodyPr>
           <a:lstStyle/>
           <a:p>
-            <a:pPr algn="l" indent="0" marL="0">
+            <a:pPr marL="0" indent="0" algn="l">
               <a:buNone/>
             </a:pPr>
             <a:r>
@@ -9327,7 +8873,7 @@
           </a:bodyPr>
           <a:lstStyle/>
           <a:p>
-            <a:pPr algn="l" indent="0" marL="0">
+            <a:pPr marL="0" indent="0" algn="l">
               <a:buNone/>
             </a:pPr>
             <a:r>
@@ -9368,7 +8914,7 @@
           </a:bodyPr>
           <a:lstStyle/>
           <a:p>
-            <a:pPr algn="l" indent="0" marL="0">
+            <a:pPr marL="0" indent="0" algn="l">
               <a:lnSpc>
                 <a:spcPct val="112000"/>
               </a:lnSpc>
@@ -9412,7 +8958,7 @@
           </a:bodyPr>
           <a:lstStyle/>
           <a:p>
-            <a:pPr algn="l" indent="0" marL="0">
+            <a:pPr marL="0" indent="0" algn="l">
               <a:buNone/>
             </a:pPr>
             <a:r>
@@ -9453,7 +8999,7 @@
           </a:bodyPr>
           <a:lstStyle/>
           <a:p>
-            <a:pPr algn="l" indent="0" marL="0">
+            <a:pPr marL="0" indent="0" algn="l">
               <a:buNone/>
             </a:pPr>
             <a:r>
@@ -9494,7 +9040,7 @@
           </a:bodyPr>
           <a:lstStyle/>
           <a:p>
-            <a:pPr algn="l" indent="0" marL="0">
+            <a:pPr marL="0" indent="0" algn="l">
               <a:lnSpc>
                 <a:spcPct val="112000"/>
               </a:lnSpc>
@@ -9538,7 +9084,7 @@
           </a:bodyPr>
           <a:lstStyle/>
           <a:p>
-            <a:pPr algn="l" indent="0" marL="0">
+            <a:pPr marL="0" indent="0" algn="l">
               <a:lnSpc>
                 <a:spcPct val="112000"/>
               </a:lnSpc>
@@ -9593,7 +9139,7 @@
           <p:nvPr/>
         </p:nvPicPr>
         <p:blipFill>
-          <a:blip r:embed="rId1"/>
+          <a:blip r:embed="rId3"/>
           <a:stretch>
             <a:fillRect/>
           </a:stretch>
@@ -9631,7 +9177,7 @@
           </a:bodyPr>
           <a:lstStyle/>
           <a:p>
-            <a:pPr algn="l" indent="0" marL="0">
+            <a:pPr marL="0" indent="0" algn="l">
               <a:buNone/>
             </a:pPr>
             <a:r>
@@ -9672,7 +9218,7 @@
           </a:bodyPr>
           <a:lstStyle/>
           <a:p>
-            <a:pPr algn="l" indent="0" marL="0">
+            <a:pPr marL="0" indent="0" algn="l">
               <a:lnSpc>
                 <a:spcPct val="112000"/>
               </a:lnSpc>
@@ -9716,7 +9262,7 @@
           </a:bodyPr>
           <a:lstStyle/>
           <a:p>
-            <a:pPr algn="l" indent="0" marL="0">
+            <a:pPr marL="0" indent="0" algn="l">
               <a:buNone/>
             </a:pPr>
             <a:r>
@@ -9757,7 +9303,7 @@
           </a:bodyPr>
           <a:lstStyle/>
           <a:p>
-            <a:pPr algn="l" indent="0" marL="0">
+            <a:pPr marL="0" indent="0" algn="l">
               <a:buNone/>
             </a:pPr>
             <a:r>
@@ -9798,7 +9344,7 @@
           </a:bodyPr>
           <a:lstStyle/>
           <a:p>
-            <a:pPr algn="l" indent="0" marL="0">
+            <a:pPr marL="0" indent="0" algn="l">
               <a:lnSpc>
                 <a:spcPct val="120000"/>
               </a:lnSpc>
@@ -9813,7 +9359,7 @@
                 <a:ea typeface="Space Grotesk" pitchFamily="34" charset="-122"/>
                 <a:cs typeface="Space Grotesk" pitchFamily="34" charset="-120"/>
               </a:rPr>
-              <a:t xml:space="preserve">Choose </a:t>
+              <a:t>Choose </a:t>
             </a:r>
             <a:r>
               <a:rPr lang="en-US" sz="800" b="1" dirty="0">
@@ -9835,7 +9381,7 @@
                 <a:ea typeface="Space Grotesk" pitchFamily="34" charset="-122"/>
                 <a:cs typeface="Space Grotesk" pitchFamily="34" charset="-120"/>
               </a:rPr>
-              <a:t xml:space="preserve"> for general projects or </a:t>
+              <a:t> for general projects or </a:t>
             </a:r>
             <a:r>
               <a:rPr lang="en-US" sz="800" b="1" dirty="0">
@@ -9857,7 +9403,7 @@
                 <a:ea typeface="Space Grotesk" pitchFamily="34" charset="-122"/>
                 <a:cs typeface="Space Grotesk" pitchFamily="34" charset="-120"/>
               </a:rPr>
-              <a:t xml:space="preserve"> for engineering-intensive work.</a:t>
+              <a:t> for engineering-intensive work.</a:t>
             </a:r>
             <a:endParaRPr lang="en-US" sz="850" dirty="0"/>
           </a:p>
@@ -9886,7 +9432,7 @@
           </a:bodyPr>
           <a:lstStyle/>
           <a:p>
-            <a:pPr algn="l" indent="0" marL="0">
+            <a:pPr marL="0" indent="0" algn="l">
               <a:buNone/>
             </a:pPr>
             <a:r>
@@ -9927,7 +9473,7 @@
           </a:bodyPr>
           <a:lstStyle/>
           <a:p>
-            <a:pPr algn="l" indent="0" marL="0">
+            <a:pPr marL="0" indent="0" algn="l">
               <a:buNone/>
             </a:pPr>
             <a:r>
@@ -9968,7 +9514,7 @@
           </a:bodyPr>
           <a:lstStyle/>
           <a:p>
-            <a:pPr algn="l" indent="0" marL="0">
+            <a:pPr marL="0" indent="0" algn="l">
               <a:lnSpc>
                 <a:spcPct val="120000"/>
               </a:lnSpc>
@@ -10012,7 +9558,7 @@
           </a:bodyPr>
           <a:lstStyle/>
           <a:p>
-            <a:pPr algn="l" indent="0" marL="0">
+            <a:pPr marL="0" indent="0" algn="l">
               <a:buNone/>
             </a:pPr>
             <a:r>
@@ -10053,7 +9599,7 @@
           </a:bodyPr>
           <a:lstStyle/>
           <a:p>
-            <a:pPr algn="l" indent="0" marL="0">
+            <a:pPr marL="0" indent="0" algn="l">
               <a:buNone/>
             </a:pPr>
             <a:r>
@@ -10094,7 +9640,7 @@
           </a:bodyPr>
           <a:lstStyle/>
           <a:p>
-            <a:pPr algn="l" indent="0" marL="0">
+            <a:pPr marL="0" indent="0" algn="l">
               <a:lnSpc>
                 <a:spcPct val="120000"/>
               </a:lnSpc>
@@ -10138,7 +9684,7 @@
           </a:bodyPr>
           <a:lstStyle/>
           <a:p>
-            <a:pPr algn="l" indent="0" marL="0">
+            <a:pPr marL="0" indent="0" algn="l">
               <a:buNone/>
             </a:pPr>
             <a:r>
@@ -10179,7 +9725,7 @@
           </a:bodyPr>
           <a:lstStyle/>
           <a:p>
-            <a:pPr algn="l" indent="0" marL="0">
+            <a:pPr marL="0" indent="0" algn="l">
               <a:buNone/>
             </a:pPr>
             <a:r>
@@ -10220,7 +9766,7 @@
           </a:bodyPr>
           <a:lstStyle/>
           <a:p>
-            <a:pPr algn="l" indent="0" marL="0">
+            <a:pPr marL="0" indent="0" algn="l">
               <a:lnSpc>
                 <a:spcPct val="120000"/>
               </a:lnSpc>
@@ -10264,7 +9810,7 @@
           </a:bodyPr>
           <a:lstStyle/>
           <a:p>
-            <a:pPr algn="l" indent="0" marL="0">
+            <a:pPr marL="0" indent="0" algn="l">
               <a:buNone/>
             </a:pPr>
             <a:r>
@@ -10305,7 +9851,7 @@
           </a:bodyPr>
           <a:lstStyle/>
           <a:p>
-            <a:pPr algn="l" indent="0" marL="0">
+            <a:pPr marL="0" indent="0" algn="l">
               <a:buNone/>
             </a:pPr>
             <a:r>
@@ -10346,7 +9892,7 @@
           </a:bodyPr>
           <a:lstStyle/>
           <a:p>
-            <a:pPr algn="l" indent="0" marL="0">
+            <a:pPr marL="0" indent="0" algn="l">
               <a:lnSpc>
                 <a:spcPct val="120000"/>
               </a:lnSpc>
@@ -10401,7 +9947,7 @@
           <p:nvPr/>
         </p:nvPicPr>
         <p:blipFill>
-          <a:blip r:embed="rId1"/>
+          <a:blip r:embed="rId3"/>
           <a:stretch>
             <a:fillRect/>
           </a:stretch>
@@ -10439,7 +9985,7 @@
           </a:bodyPr>
           <a:lstStyle/>
           <a:p>
-            <a:pPr algn="l" indent="0" marL="0">
+            <a:pPr marL="0" indent="0" algn="l">
               <a:buNone/>
             </a:pPr>
             <a:r>
@@ -10480,7 +10026,7 @@
           </a:bodyPr>
           <a:lstStyle/>
           <a:p>
-            <a:pPr algn="l" indent="0" marL="0">
+            <a:pPr marL="0" indent="0" algn="l">
               <a:lnSpc>
                 <a:spcPct val="112000"/>
               </a:lnSpc>
@@ -10524,7 +10070,7 @@
           </a:bodyPr>
           <a:lstStyle/>
           <a:p>
-            <a:pPr algn="l" indent="0" marL="0">
+            <a:pPr marL="0" indent="0" algn="l">
               <a:buNone/>
             </a:pPr>
             <a:r>
@@ -10565,7 +10111,7 @@
           </a:bodyPr>
           <a:lstStyle/>
           <a:p>
-            <a:pPr algn="l" indent="0" marL="0">
+            <a:pPr marL="0" indent="0" algn="l">
               <a:lnSpc>
                 <a:spcPct val="112000"/>
               </a:lnSpc>
@@ -10609,7 +10155,7 @@
           </a:bodyPr>
           <a:lstStyle/>
           <a:p>
-            <a:pPr algn="l" indent="0" marL="0">
+            <a:pPr marL="0" indent="0" algn="l">
               <a:buNone/>
             </a:pPr>
             <a:r>
@@ -10650,7 +10196,7 @@
           </a:bodyPr>
           <a:lstStyle/>
           <a:p>
-            <a:pPr algn="l" indent="0" marL="0">
+            <a:pPr marL="0" indent="0" algn="l">
               <a:lnSpc>
                 <a:spcPct val="112000"/>
               </a:lnSpc>
@@ -10694,7 +10240,7 @@
           </a:bodyPr>
           <a:lstStyle/>
           <a:p>
-            <a:pPr algn="l" indent="0" marL="0">
+            <a:pPr marL="0" indent="0" algn="l">
               <a:buNone/>
             </a:pPr>
             <a:r>
@@ -10735,7 +10281,7 @@
           </a:bodyPr>
           <a:lstStyle/>
           <a:p>
-            <a:pPr algn="l" indent="0" marL="0">
+            <a:pPr marL="0" indent="0" algn="l">
               <a:lnSpc>
                 <a:spcPct val="112000"/>
               </a:lnSpc>
@@ -10779,7 +10325,7 @@
           </a:bodyPr>
           <a:lstStyle/>
           <a:p>
-            <a:pPr algn="l" indent="0" marL="0">
+            <a:pPr marL="0" indent="0" algn="l">
               <a:buNone/>
             </a:pPr>
             <a:r>
@@ -10820,7 +10366,7 @@
           </a:bodyPr>
           <a:lstStyle/>
           <a:p>
-            <a:pPr algn="l" indent="0" marL="0">
+            <a:pPr marL="0" indent="0" algn="l">
               <a:lnSpc>
                 <a:spcPct val="112000"/>
               </a:lnSpc>
@@ -10864,7 +10410,7 @@
           </a:bodyPr>
           <a:lstStyle/>
           <a:p>
-            <a:pPr algn="l" indent="0" marL="0">
+            <a:pPr marL="0" indent="0" algn="l">
               <a:buNone/>
             </a:pPr>
             <a:r>
@@ -10905,7 +10451,7 @@
           </a:bodyPr>
           <a:lstStyle/>
           <a:p>
-            <a:pPr algn="l" indent="0" marL="0">
+            <a:pPr marL="0" indent="0" algn="l">
               <a:lnSpc>
                 <a:spcPct val="112000"/>
               </a:lnSpc>
@@ -10949,7 +10495,7 @@
           </a:bodyPr>
           <a:lstStyle/>
           <a:p>
-            <a:pPr algn="l" indent="0" marL="0">
+            <a:pPr marL="0" indent="0" algn="l">
               <a:buNone/>
             </a:pPr>
             <a:r>
@@ -10990,7 +10536,7 @@
           </a:bodyPr>
           <a:lstStyle/>
           <a:p>
-            <a:pPr algn="l" indent="0" marL="0">
+            <a:pPr marL="0" indent="0" algn="l">
               <a:lnSpc>
                 <a:spcPct val="112000"/>
               </a:lnSpc>
@@ -11034,7 +10580,7 @@
           </a:bodyPr>
           <a:lstStyle/>
           <a:p>
-            <a:pPr algn="l" indent="0" marL="0">
+            <a:pPr marL="0" indent="0" algn="l">
               <a:buNone/>
             </a:pPr>
             <a:r>
@@ -11075,7 +10621,7 @@
           </a:bodyPr>
           <a:lstStyle/>
           <a:p>
-            <a:pPr algn="l" indent="0" marL="0">
+            <a:pPr marL="0" indent="0" algn="l">
               <a:lnSpc>
                 <a:spcPct val="112000"/>
               </a:lnSpc>
@@ -11119,7 +10665,7 @@
           </a:bodyPr>
           <a:lstStyle/>
           <a:p>
-            <a:pPr algn="l" indent="0" marL="0">
+            <a:pPr marL="0" indent="0" algn="l">
               <a:buNone/>
             </a:pPr>
             <a:r>
@@ -11160,7 +10706,7 @@
           </a:bodyPr>
           <a:lstStyle/>
           <a:p>
-            <a:pPr algn="l" indent="0" marL="0">
+            <a:pPr marL="0" indent="0" algn="l">
               <a:lnSpc>
                 <a:spcPct val="112000"/>
               </a:lnSpc>
@@ -11204,7 +10750,7 @@
           </a:bodyPr>
           <a:lstStyle/>
           <a:p>
-            <a:pPr algn="l" indent="0" marL="0">
+            <a:pPr marL="0" indent="0" algn="l">
               <a:buNone/>
             </a:pPr>
             <a:r>
@@ -11245,7 +10791,7 @@
           </a:bodyPr>
           <a:lstStyle/>
           <a:p>
-            <a:pPr algn="l" indent="0" marL="0">
+            <a:pPr marL="0" indent="0" algn="l">
               <a:lnSpc>
                 <a:spcPct val="112000"/>
               </a:lnSpc>
@@ -11289,7 +10835,7 @@
           </a:bodyPr>
           <a:lstStyle/>
           <a:p>
-            <a:pPr algn="l" indent="0" marL="0">
+            <a:pPr marL="0" indent="0" algn="l">
               <a:buNone/>
             </a:pPr>
             <a:r>
@@ -11330,7 +10876,7 @@
           </a:bodyPr>
           <a:lstStyle/>
           <a:p>
-            <a:pPr algn="l" indent="0" marL="0">
+            <a:pPr marL="0" indent="0" algn="l">
               <a:lnSpc>
                 <a:spcPct val="112000"/>
               </a:lnSpc>
@@ -11359,8 +10905,8 @@
         </p:nvSpPr>
         <p:spPr>
           <a:xfrm>
-            <a:off x="857250" y="4648014"/>
-            <a:ext cx="7715250" cy="517196"/>
+            <a:off x="195944" y="4648014"/>
+            <a:ext cx="8889274" cy="318549"/>
           </a:xfrm>
           <a:prstGeom prst="rect">
             <a:avLst/>
@@ -11374,7 +10920,7 @@
           </a:bodyPr>
           <a:lstStyle/>
           <a:p>
-            <a:pPr algn="l" indent="0" marL="0">
+            <a:pPr marL="0" indent="0" algn="l">
               <a:lnSpc>
                 <a:spcPct val="112000"/>
               </a:lnSpc>
@@ -11696,4 +11242,319 @@
     </a:ext>
   </a:extLst>
 </a:theme>
+</file>
+
+<file path=ppt/theme/theme2.xml><?xml version="1.0" encoding="utf-8"?>
+<a:theme xmlns:a="http://schemas.openxmlformats.org/drawingml/2006/main" name="Office Theme">
+  <a:themeElements>
+    <a:clrScheme name="Office">
+      <a:dk1>
+        <a:sysClr val="windowText" lastClr="000000"/>
+      </a:dk1>
+      <a:lt1>
+        <a:sysClr val="window" lastClr="FFFFFF"/>
+      </a:lt1>
+      <a:dk2>
+        <a:srgbClr val="0E2841"/>
+      </a:dk2>
+      <a:lt2>
+        <a:srgbClr val="E8E8E8"/>
+      </a:lt2>
+      <a:accent1>
+        <a:srgbClr val="156082"/>
+      </a:accent1>
+      <a:accent2>
+        <a:srgbClr val="E97132"/>
+      </a:accent2>
+      <a:accent3>
+        <a:srgbClr val="196B24"/>
+      </a:accent3>
+      <a:accent4>
+        <a:srgbClr val="0F9ED5"/>
+      </a:accent4>
+      <a:accent5>
+        <a:srgbClr val="A02B93"/>
+      </a:accent5>
+      <a:accent6>
+        <a:srgbClr val="4EA72E"/>
+      </a:accent6>
+      <a:hlink>
+        <a:srgbClr val="467886"/>
+      </a:hlink>
+      <a:folHlink>
+        <a:srgbClr val="96607D"/>
+      </a:folHlink>
+    </a:clrScheme>
+    <a:fontScheme name="Office">
+      <a:majorFont>
+        <a:latin typeface="Aptos Display" panose="02110004020202020204"/>
+        <a:ea typeface=""/>
+        <a:cs typeface=""/>
+        <a:font script="Jpan" typeface="游ゴシック Light"/>
+        <a:font script="Hang" typeface="맑은 고딕"/>
+        <a:font script="Hans" typeface="等线 Light"/>
+        <a:font script="Hant" typeface="新細明體"/>
+        <a:font script="Arab" typeface="Times New Roman"/>
+        <a:font script="Hebr" typeface="Times New Roman"/>
+        <a:font script="Thai" typeface="Angsana New"/>
+        <a:font script="Ethi" typeface="Nyala"/>
+        <a:font script="Beng" typeface="Vrinda"/>
+        <a:font script="Gujr" typeface="Shruti"/>
+        <a:font script="Khmr" typeface="MoolBoran"/>
+        <a:font script="Knda" typeface="Tunga"/>
+        <a:font script="Guru" typeface="Raavi"/>
+        <a:font script="Cans" typeface="Euphemia"/>
+        <a:font script="Cher" typeface="Plantagenet Cherokee"/>
+        <a:font script="Yiii" typeface="Microsoft Yi Baiti"/>
+        <a:font script="Tibt" typeface="Microsoft Himalaya"/>
+        <a:font script="Thaa" typeface="MV Boli"/>
+        <a:font script="Deva" typeface="Mangal"/>
+        <a:font script="Telu" typeface="Gautami"/>
+        <a:font script="Taml" typeface="Latha"/>
+        <a:font script="Syrc" typeface="Estrangelo Edessa"/>
+        <a:font script="Orya" typeface="Kalinga"/>
+        <a:font script="Mlym" typeface="Kartika"/>
+        <a:font script="Laoo" typeface="DokChampa"/>
+        <a:font script="Sinh" typeface="Iskoola Pota"/>
+        <a:font script="Mong" typeface="Mongolian Baiti"/>
+        <a:font script="Viet" typeface="Times New Roman"/>
+        <a:font script="Uigh" typeface="Microsoft Uighur"/>
+        <a:font script="Geor" typeface="Sylfaen"/>
+        <a:font script="Armn" typeface="Arial"/>
+        <a:font script="Bugi" typeface="Leelawadee UI"/>
+        <a:font script="Bopo" typeface="Microsoft JhengHei"/>
+        <a:font script="Java" typeface="Javanese Text"/>
+        <a:font script="Lisu" typeface="Segoe UI"/>
+        <a:font script="Mymr" typeface="Myanmar Text"/>
+        <a:font script="Nkoo" typeface="Ebrima"/>
+        <a:font script="Olck" typeface="Nirmala UI"/>
+        <a:font script="Osma" typeface="Ebrima"/>
+        <a:font script="Phag" typeface="Phagspa"/>
+        <a:font script="Syrn" typeface="Estrangelo Edessa"/>
+        <a:font script="Syrj" typeface="Estrangelo Edessa"/>
+        <a:font script="Syre" typeface="Estrangelo Edessa"/>
+        <a:font script="Sora" typeface="Nirmala UI"/>
+        <a:font script="Tale" typeface="Microsoft Tai Le"/>
+        <a:font script="Talu" typeface="Microsoft New Tai Lue"/>
+        <a:font script="Tfng" typeface="Ebrima"/>
+      </a:majorFont>
+      <a:minorFont>
+        <a:latin typeface="Aptos" panose="02110004020202020204"/>
+        <a:ea typeface=""/>
+        <a:cs typeface=""/>
+        <a:font script="Jpan" typeface="游ゴシック"/>
+        <a:font script="Hang" typeface="맑은 고딕"/>
+        <a:font script="Hans" typeface="等线"/>
+        <a:font script="Hant" typeface="新細明體"/>
+        <a:font script="Arab" typeface="Arial"/>
+        <a:font script="Hebr" typeface="Arial"/>
+        <a:font script="Thai" typeface="Cordia New"/>
+        <a:font script="Ethi" typeface="Nyala"/>
+        <a:font script="Beng" typeface="Vrinda"/>
+        <a:font script="Gujr" typeface="Shruti"/>
+        <a:font script="Khmr" typeface="DaunPenh"/>
+        <a:font script="Knda" typeface="Tunga"/>
+        <a:font script="Guru" typeface="Raavi"/>
+        <a:font script="Cans" typeface="Euphemia"/>
+        <a:font script="Cher" typeface="Plantagenet Cherokee"/>
+        <a:font script="Yiii" typeface="Microsoft Yi Baiti"/>
+        <a:font script="Tibt" typeface="Microsoft Himalaya"/>
+        <a:font script="Thaa" typeface="MV Boli"/>
+        <a:font script="Deva" typeface="Mangal"/>
+        <a:font script="Telu" typeface="Gautami"/>
+        <a:font script="Taml" typeface="Latha"/>
+        <a:font script="Syrc" typeface="Estrangelo Edessa"/>
+        <a:font script="Orya" typeface="Kalinga"/>
+        <a:font script="Mlym" typeface="Kartika"/>
+        <a:font script="Laoo" typeface="DokChampa"/>
+        <a:font script="Sinh" typeface="Iskoola Pota"/>
+        <a:font script="Mong" typeface="Mongolian Baiti"/>
+        <a:font script="Viet" typeface="Arial"/>
+        <a:font script="Uigh" typeface="Microsoft Uighur"/>
+        <a:font script="Geor" typeface="Sylfaen"/>
+        <a:font script="Armn" typeface="Arial"/>
+        <a:font script="Bugi" typeface="Leelawadee UI"/>
+        <a:font script="Bopo" typeface="Microsoft JhengHei"/>
+        <a:font script="Java" typeface="Javanese Text"/>
+        <a:font script="Lisu" typeface="Segoe UI"/>
+        <a:font script="Mymr" typeface="Myanmar Text"/>
+        <a:font script="Nkoo" typeface="Ebrima"/>
+        <a:font script="Olck" typeface="Nirmala UI"/>
+        <a:font script="Osma" typeface="Ebrima"/>
+        <a:font script="Phag" typeface="Phagspa"/>
+        <a:font script="Syrn" typeface="Estrangelo Edessa"/>
+        <a:font script="Syrj" typeface="Estrangelo Edessa"/>
+        <a:font script="Syre" typeface="Estrangelo Edessa"/>
+        <a:font script="Sora" typeface="Nirmala UI"/>
+        <a:font script="Tale" typeface="Microsoft Tai Le"/>
+        <a:font script="Talu" typeface="Microsoft New Tai Lue"/>
+        <a:font script="Tfng" typeface="Ebrima"/>
+      </a:minorFont>
+    </a:fontScheme>
+    <a:fmtScheme name="Office">
+      <a:fillStyleLst>
+        <a:solidFill>
+          <a:schemeClr val="phClr"/>
+        </a:solidFill>
+        <a:gradFill rotWithShape="1">
+          <a:gsLst>
+            <a:gs pos="0">
+              <a:schemeClr val="phClr">
+                <a:lumMod val="110000"/>
+                <a:satMod val="105000"/>
+                <a:tint val="67000"/>
+              </a:schemeClr>
+            </a:gs>
+            <a:gs pos="50000">
+              <a:schemeClr val="phClr">
+                <a:lumMod val="105000"/>
+                <a:satMod val="103000"/>
+                <a:tint val="73000"/>
+              </a:schemeClr>
+            </a:gs>
+            <a:gs pos="100000">
+              <a:schemeClr val="phClr">
+                <a:lumMod val="105000"/>
+                <a:satMod val="109000"/>
+                <a:tint val="81000"/>
+              </a:schemeClr>
+            </a:gs>
+          </a:gsLst>
+          <a:lin ang="5400000" scaled="0"/>
+        </a:gradFill>
+        <a:gradFill rotWithShape="1">
+          <a:gsLst>
+            <a:gs pos="0">
+              <a:schemeClr val="phClr">
+                <a:satMod val="103000"/>
+                <a:lumMod val="102000"/>
+                <a:tint val="94000"/>
+              </a:schemeClr>
+            </a:gs>
+            <a:gs pos="50000">
+              <a:schemeClr val="phClr">
+                <a:satMod val="110000"/>
+                <a:lumMod val="100000"/>
+                <a:shade val="100000"/>
+              </a:schemeClr>
+            </a:gs>
+            <a:gs pos="100000">
+              <a:schemeClr val="phClr">
+                <a:lumMod val="99000"/>
+                <a:satMod val="120000"/>
+                <a:shade val="78000"/>
+              </a:schemeClr>
+            </a:gs>
+          </a:gsLst>
+          <a:lin ang="5400000" scaled="0"/>
+        </a:gradFill>
+      </a:fillStyleLst>
+      <a:lnStyleLst>
+        <a:ln w="12700" cap="flat" cmpd="sng" algn="ctr">
+          <a:solidFill>
+            <a:schemeClr val="phClr"/>
+          </a:solidFill>
+          <a:prstDash val="solid"/>
+          <a:miter lim="800000"/>
+        </a:ln>
+        <a:ln w="19050" cap="flat" cmpd="sng" algn="ctr">
+          <a:solidFill>
+            <a:schemeClr val="phClr"/>
+          </a:solidFill>
+          <a:prstDash val="solid"/>
+          <a:miter lim="800000"/>
+        </a:ln>
+        <a:ln w="25400" cap="flat" cmpd="sng" algn="ctr">
+          <a:solidFill>
+            <a:schemeClr val="phClr"/>
+          </a:solidFill>
+          <a:prstDash val="solid"/>
+          <a:miter lim="800000"/>
+        </a:ln>
+      </a:lnStyleLst>
+      <a:effectStyleLst>
+        <a:effectStyle>
+          <a:effectLst/>
+        </a:effectStyle>
+        <a:effectStyle>
+          <a:effectLst/>
+        </a:effectStyle>
+        <a:effectStyle>
+          <a:effectLst>
+            <a:outerShdw blurRad="57150" dist="19050" dir="5400000" algn="ctr" rotWithShape="0">
+              <a:srgbClr val="000000">
+                <a:alpha val="63000"/>
+              </a:srgbClr>
+            </a:outerShdw>
+          </a:effectLst>
+        </a:effectStyle>
+      </a:effectStyleLst>
+      <a:bgFillStyleLst>
+        <a:solidFill>
+          <a:schemeClr val="phClr"/>
+        </a:solidFill>
+        <a:solidFill>
+          <a:schemeClr val="phClr">
+            <a:tint val="95000"/>
+            <a:satMod val="170000"/>
+          </a:schemeClr>
+        </a:solidFill>
+        <a:gradFill rotWithShape="1">
+          <a:gsLst>
+            <a:gs pos="0">
+              <a:schemeClr val="phClr">
+                <a:tint val="93000"/>
+                <a:satMod val="150000"/>
+                <a:shade val="98000"/>
+                <a:lumMod val="102000"/>
+              </a:schemeClr>
+            </a:gs>
+            <a:gs pos="50000">
+              <a:schemeClr val="phClr">
+                <a:tint val="98000"/>
+                <a:satMod val="130000"/>
+                <a:shade val="90000"/>
+                <a:lumMod val="103000"/>
+              </a:schemeClr>
+            </a:gs>
+            <a:gs pos="100000">
+              <a:schemeClr val="phClr">
+                <a:shade val="63000"/>
+                <a:satMod val="120000"/>
+              </a:schemeClr>
+            </a:gs>
+          </a:gsLst>
+          <a:lin ang="5400000" scaled="0"/>
+        </a:gradFill>
+      </a:bgFillStyleLst>
+    </a:fmtScheme>
+  </a:themeElements>
+  <a:objectDefaults>
+    <a:lnDef>
+      <a:spPr/>
+      <a:bodyPr/>
+      <a:lstStyle/>
+      <a:style>
+        <a:lnRef idx="2">
+          <a:schemeClr val="accent1"/>
+        </a:lnRef>
+        <a:fillRef idx="0">
+          <a:schemeClr val="accent1"/>
+        </a:fillRef>
+        <a:effectRef idx="1">
+          <a:schemeClr val="accent1"/>
+        </a:effectRef>
+        <a:fontRef idx="minor">
+          <a:schemeClr val="tx1"/>
+        </a:fontRef>
+      </a:style>
+    </a:lnDef>
+  </a:objectDefaults>
+  <a:extraClrSchemeLst/>
+  <a:extLst>
+    <a:ext uri="{05A4C25C-085E-4340-85A3-A5531E510DB2}">
+      <thm15:themeFamily xmlns:thm15="http://schemas.microsoft.com/office/thememl/2012/main" name="Office Theme" id="{2E142A2C-CD16-42D6-873A-C26D2A0506FA}" vid="{1BDDFF52-6CD6-40A5-AB3C-68EB2F1E4D0A}"/>
+    </a:ext>
+  </a:extLst>
+</a:theme>
 </file>
</xml_diff>

<commit_message>
Add recommended folder structure slide to PPTX and PDF
New slide 9 covers the .ai/ parent directory convention and the
skills/, memory/, tools/ shared folders — matching the content
already in Templates/README.md. Two-column layout: monospace
folder tree on the left, explanations on the right.

Co-Authored-By: Claude Sonnet 4.6 <noreply@anthropic.com>
</commit_message>
<xml_diff>
--- a/Interpretable_Context_Methodology_(ICM).pptx
+++ b/Interpretable_Context_Methodology_(ICM).pptx
@@ -16,6 +16,7 @@
     <p:sldId id="261" r:id="rId7"/>
     <p:sldId id="262" r:id="rId8"/>
     <p:sldId id="263" r:id="rId9"/>
+    <p:sldId id="268" r:id="rId19"/>
     <p:sldId id="264" r:id="rId10"/>
     <p:sldId id="265" r:id="rId11"/>
     <p:sldId id="266" r:id="rId12"/>
@@ -577,6 +578,85 @@
         <p14:creationId xmlns:p14="http://schemas.microsoft.com/office/powerpoint/2010/main" val="1024086991"/>
       </p:ext>
     </p:extLst>
+  </p:cSld>
+  <p:clrMapOvr>
+    <a:masterClrMapping/>
+  </p:clrMapOvr>
+</p:notes>
+</file>
+
+<file path=ppt/notesSlides/notesSlide13.xml><?xml version="1.0" encoding="utf-8"?>
+<p:notes xmlns:a="http://schemas.openxmlformats.org/drawingml/2006/main" xmlns:r="http://schemas.openxmlformats.org/officeDocument/2006/relationships" xmlns:p="http://schemas.openxmlformats.org/presentationml/2006/main">
+  <p:cSld>
+    <p:spTree>
+      <p:nvGrpSpPr>
+        <p:cNvPr id="1" name=""/>
+        <p:cNvGrpSpPr/>
+        <p:nvPr/>
+      </p:nvGrpSpPr>
+      <p:grpSpPr>
+        <a:xfrm>
+          <a:off x="0" y="0"/>
+          <a:ext cx="0" cy="0"/>
+          <a:chOff x="0" y="0"/>
+          <a:chExt cx="0" cy="0"/>
+        </a:xfrm>
+      </p:grpSpPr>
+      <p:sp>
+        <p:nvSpPr>
+          <p:cNvPr id="2" name="Slide Image Placeholder 1"/>
+          <p:cNvSpPr>
+            <a:spLocks noGrp="1" noRot="1" noChangeAspect="1"/>
+          </p:cNvSpPr>
+          <p:nvPr>
+            <p:ph type="sldImg"/>
+          </p:nvPr>
+        </p:nvSpPr>
+        <p:spPr/>
+      </p:sp>
+      <p:sp>
+        <p:nvSpPr>
+          <p:cNvPr id="3" name="Notes Placeholder 2"/>
+          <p:cNvSpPr>
+            <a:spLocks noGrp="1"/>
+          </p:cNvSpPr>
+          <p:nvPr>
+            <p:ph type="body" idx="1"/>
+          </p:nvPr>
+        </p:nvSpPr>
+        <p:spPr/>
+        <p:txBody>
+          <a:bodyPr/>
+          <a:lstStyle/>
+          <a:p>
+            <a:endParaRPr lang="en-US" dirty="0"/>
+          </a:p>
+        </p:txBody>
+      </p:sp>
+      <p:sp>
+        <p:nvSpPr>
+          <p:cNvPr id="4" name="Slide Number Placeholder 3"/>
+          <p:cNvSpPr>
+            <a:spLocks noGrp="1"/>
+          </p:cNvSpPr>
+          <p:nvPr>
+            <p:ph type="sldNum" sz="quarter" idx="10"/>
+          </p:nvPr>
+        </p:nvSpPr>
+        <p:spPr/>
+        <p:txBody>
+          <a:bodyPr/>
+          <a:lstStyle/>
+          <a:p>
+            <a:fld id="{A1B2C3D4-E5F6-7890-ABCD-EF1234567890}" type="slidenum">
+              <a:rPr lang="en-US"/>
+              <a:t>13</a:t>
+            </a:fld>
+            <a:endParaRPr lang="en-US"/>
+          </a:p>
+        </p:txBody>
+      </p:sp>
+    </p:spTree>
   </p:cSld>
   <p:clrMapOvr>
     <a:masterClrMapping/>
@@ -1923,7 +2003,7 @@
                 <a:ea typeface="Space Grotesk" pitchFamily="34" charset="-122"/>
                 <a:cs typeface="Space Grotesk" pitchFamily="34" charset="-120"/>
               </a:rPr>
-              <a:t> provides </a:t>
+              <a:t xml:space="preserve"> provides </a:t>
             </a:r>
             <a:r>
               <a:rPr lang="en-US" sz="900" b="1" dirty="0">
@@ -1945,7 +2025,7 @@
                 <a:ea typeface="Space Grotesk" pitchFamily="34" charset="-122"/>
                 <a:cs typeface="Space Grotesk" pitchFamily="34" charset="-120"/>
               </a:rPr>
-              <a:t> — the AI agent can resume work across sessions without losing context.</a:t>
+              <a:t xml:space="preserve"> — the AI agent can resume work across sessions without losing context.</a:t>
             </a:r>
             <a:endParaRPr lang="en-US" sz="1000" dirty="0"/>
           </a:p>
@@ -2000,7 +2080,7 @@
                 <a:ea typeface="Space Grotesk" pitchFamily="34" charset="-122"/>
                 <a:cs typeface="Space Grotesk" pitchFamily="34" charset="-120"/>
               </a:rPr>
-              <a:t> creates a </a:t>
+              <a:t xml:space="preserve"> creates a </a:t>
             </a:r>
             <a:r>
               <a:rPr lang="en-US" sz="900" b="1" dirty="0">
@@ -2022,7 +2102,7 @@
                 <a:ea typeface="Space Grotesk" pitchFamily="34" charset="-122"/>
                 <a:cs typeface="Space Grotesk" pitchFamily="34" charset="-120"/>
               </a:rPr>
-              <a:t> — every significant choice is recorded with its rationale, supporting audit and governance requirements.</a:t>
+              <a:t xml:space="preserve"> — every significant choice is recorded with its rationale, supporting audit and governance requirements.</a:t>
             </a:r>
             <a:endParaRPr lang="en-US" sz="1000" dirty="0"/>
           </a:p>
@@ -2077,7 +2157,7 @@
                 <a:ea typeface="Space Grotesk" pitchFamily="34" charset="-122"/>
                 <a:cs typeface="Space Grotesk" pitchFamily="34" charset="-120"/>
               </a:rPr>
-              <a:t> encodes </a:t>
+              <a:t xml:space="preserve"> encodes </a:t>
             </a:r>
             <a:r>
               <a:rPr lang="en-US" sz="900" b="1" dirty="0">
@@ -2099,7 +2179,7 @@
                 <a:ea typeface="Space Grotesk" pitchFamily="34" charset="-122"/>
                 <a:cs typeface="Space Grotesk" pitchFamily="34" charset="-120"/>
               </a:rPr>
-              <a:t> — coding standards, naming conventions, and compliance rules are stored as files the agent can read and enforce.</a:t>
+              <a:t xml:space="preserve"> — coding standards, naming conventions, and compliance rules are stored as files the agent can read and enforce.</a:t>
             </a:r>
             <a:endParaRPr lang="en-US" sz="1000" dirty="0"/>
           </a:p>
@@ -2154,7 +2234,7 @@
                 <a:ea typeface="Space Grotesk" pitchFamily="34" charset="-122"/>
                 <a:cs typeface="Space Grotesk" pitchFamily="34" charset="-120"/>
               </a:rPr>
-              <a:t> transforms the ICM repository into a </a:t>
+              <a:t xml:space="preserve"> transforms the ICM repository into a </a:t>
             </a:r>
             <a:r>
               <a:rPr lang="en-US" sz="900" b="1" dirty="0">
@@ -2176,7 +2256,7 @@
                 <a:ea typeface="Space Grotesk" pitchFamily="34" charset="-122"/>
                 <a:cs typeface="Space Grotesk" pitchFamily="34" charset="-120"/>
               </a:rPr>
-              <a:t> — every change to context, workflow, or standards is tracked over time.</a:t>
+              <a:t xml:space="preserve"> — every change to context, workflow, or standards is tracked over time.</a:t>
             </a:r>
             <a:endParaRPr lang="en-US" sz="900" dirty="0"/>
           </a:p>
@@ -2220,7 +2300,7 @@
                 <a:ea typeface="Space Grotesk" pitchFamily="34" charset="-122"/>
                 <a:cs typeface="Space Grotesk" pitchFamily="34" charset="-120"/>
               </a:rPr>
-              <a:t>ICM repositories should be treated as </a:t>
+              <a:t xml:space="preserve">ICM repositories should be treated as </a:t>
             </a:r>
             <a:r>
               <a:rPr lang="en-US" sz="1000" b="1" dirty="0">
@@ -2242,7 +2322,7 @@
                 <a:ea typeface="Space Grotesk" pitchFamily="34" charset="-122"/>
                 <a:cs typeface="Space Grotesk" pitchFamily="34" charset="-120"/>
               </a:rPr>
-              <a:t> — they are operational systems, not disposable scaffolds.</a:t>
+              <a:t xml:space="preserve"> — they are operational systems, not disposable scaffolds.</a:t>
             </a:r>
             <a:endParaRPr lang="en-US" sz="1050" dirty="0"/>
           </a:p>
@@ -3429,7 +3509,7 @@
                 <a:ea typeface="Space Grotesk" pitchFamily="34" charset="-122"/>
                 <a:cs typeface="Space Grotesk" pitchFamily="34" charset="-120"/>
               </a:rPr>
-              <a:t> — generic-agent-oriented-ICM for general projects; systems-engineering-ICM for engineering work.</a:t>
+              <a:t xml:space="preserve"> — generic-agent-oriented-ICM for general projects; systems-engineering-ICM for engineering work.</a:t>
             </a:r>
             <a:endParaRPr lang="en-US" sz="900" dirty="0"/>
           </a:p>
@@ -3486,7 +3566,7 @@
                 <a:ea typeface="Space Grotesk" pitchFamily="34" charset="-122"/>
                 <a:cs typeface="Space Grotesk" pitchFamily="34" charset="-120"/>
               </a:rPr>
-              <a:t> — point the AI agent at AI_PROJECT_CREATION_INSTRUCTIONS.md.</a:t>
+              <a:t xml:space="preserve"> — point the AI agent at AI_PROJECT_CREATION_INSTRUCTIONS.md.</a:t>
             </a:r>
             <a:endParaRPr lang="en-US" sz="900" dirty="0"/>
           </a:p>
@@ -3543,7 +3623,7 @@
                 <a:ea typeface="Space Grotesk" pitchFamily="34" charset="-122"/>
                 <a:cs typeface="Space Grotesk" pitchFamily="34" charset="-120"/>
               </a:rPr>
-              <a:t> — project name, purpose, domain, technical stack, workflow stages.</a:t>
+              <a:t xml:space="preserve"> — project name, purpose, domain, technical stack, workflow stages.</a:t>
             </a:r>
             <a:endParaRPr lang="en-US" sz="900" dirty="0"/>
           </a:p>
@@ -3600,7 +3680,7 @@
                 <a:ea typeface="Space Grotesk" pitchFamily="34" charset="-122"/>
                 <a:cs typeface="Space Grotesk" pitchFamily="34" charset="-120"/>
               </a:rPr>
-              <a:t> — verify routing is unambiguous and ownership is explicit.</a:t>
+              <a:t xml:space="preserve"> — verify routing is unambiguous and ownership is explicit.</a:t>
             </a:r>
             <a:endParaRPr lang="en-US" sz="900" dirty="0"/>
           </a:p>
@@ -3835,7 +3915,7 @@
                 <a:ea typeface="Space Grotesk" pitchFamily="34" charset="-122"/>
                 <a:cs typeface="Space Grotesk" pitchFamily="34" charset="-120"/>
               </a:rPr>
-              <a:t> — point AI agents at the repository; they will self-route using context files.</a:t>
+              <a:t xml:space="preserve"> — point AI agents at the repository; they will self-route using context files.</a:t>
             </a:r>
             <a:endParaRPr lang="en-US" sz="900" dirty="0"/>
           </a:p>
@@ -4244,6 +4324,618 @@
               <a:t>frameworks, no opaque runtime state.</a:t>
             </a:r>
             <a:endParaRPr lang="en-US" sz="950" dirty="0"/>
+          </a:p>
+        </p:txBody>
+      </p:sp>
+    </p:spTree>
+  </p:cSld>
+  <p:clrMapOvr>
+    <a:masterClrMapping/>
+  </p:clrMapOvr>
+</p:sld>
+</file>
+
+<file path=ppt/slides/slide13.xml><?xml version="1.0" encoding="utf-8"?>
+<p:sld xmlns:a="http://schemas.openxmlformats.org/drawingml/2006/main" xmlns:r="http://schemas.openxmlformats.org/officeDocument/2006/relationships" xmlns:p="http://schemas.openxmlformats.org/presentationml/2006/main">
+  <p:cSld name="Slide 13">
+    <p:spTree>
+      <p:nvGrpSpPr>
+        <p:cNvPr id="1" name=""/>
+        <p:cNvGrpSpPr/>
+        <p:nvPr/>
+      </p:nvGrpSpPr>
+      <p:grpSpPr>
+        <a:xfrm>
+          <a:off x="0" y="0"/>
+          <a:ext cx="0" cy="0"/>
+          <a:chOff x="0" y="0"/>
+          <a:chExt cx="0" cy="0"/>
+        </a:xfrm>
+      </p:grpSpPr>
+      <p:pic>
+        <p:nvPicPr>
+          <p:cNvPr id="2" name="Image 0" descr="preencoded.png"/>
+          <p:cNvPicPr>
+            <a:picLocks noChangeAspect="1"/>
+          </p:cNvPicPr>
+          <p:nvPr/>
+        </p:nvPicPr>
+        <p:blipFill>
+          <a:blip r:embed="rId3"/>
+          <a:stretch>
+            <a:fillRect/>
+          </a:stretch>
+        </p:blipFill>
+        <p:spPr>
+          <a:xfrm>
+            <a:off x="0" y="0"/>
+            <a:ext cx="9144000" cy="5143500"/>
+          </a:xfrm>
+          <a:prstGeom prst="rect">
+            <a:avLst/>
+          </a:prstGeom>
+        </p:spPr>
+      </p:pic>
+      <p:sp>
+        <p:nvSpPr>
+          <p:cNvPr id="3" name="Text 0"/>
+          <p:cNvSpPr/>
+          <p:nvPr/>
+        </p:nvSpPr>
+        <p:spPr>
+          <a:xfrm>
+            <a:off x="571500" y="342900"/>
+            <a:ext cx="8001000" cy="291108"/>
+          </a:xfrm>
+          <a:prstGeom prst="rect">
+            <a:avLst/>
+          </a:prstGeom>
+          <a:noFill/>
+          <a:ln/>
+        </p:spPr>
+        <p:txBody>
+          <a:bodyPr wrap="square" lIns="0" tIns="0" rIns="0" bIns="0" rtlCol="0" anchor="t">
+            <a:spAutoFit/>
+          </a:bodyPr>
+          <a:lstStyle/>
+          <a:p>
+            <a:pPr marL="0" indent="0" algn="l">
+              <a:buNone/>
+            </a:pPr>
+            <a:r>
+              <a:rPr lang="en-US" sz="1600" b="1" dirty="0">
+                <a:solidFill>
+                  <a:srgbClr val="111111"/>
+                </a:solidFill>
+                <a:latin typeface="Space Grotesk" pitchFamily="34" charset="0"/>
+                <a:ea typeface="Space Grotesk" pitchFamily="34" charset="-122"/>
+                <a:cs typeface="Space Grotesk" pitchFamily="34" charset="-120"/>
+              </a:rPr>
+              <a:t>RECOMMENDED FOLDER STRUCTURE</a:t>
+            </a:r>
+            <a:endParaRPr lang="en-US" sz="1600" dirty="0"/>
+          </a:p>
+        </p:txBody>
+      </p:sp>
+      <p:sp>
+        <p:nvSpPr>
+          <p:cNvPr id="4" name="Text 1"/>
+          <p:cNvSpPr/>
+          <p:nvPr/>
+        </p:nvSpPr>
+        <p:spPr>
+          <a:xfrm>
+            <a:off x="857250" y="819150"/>
+            <a:ext cx="7715250" cy="342900"/>
+          </a:xfrm>
+          <a:prstGeom prst="rect">
+            <a:avLst/>
+          </a:prstGeom>
+          <a:noFill/>
+          <a:ln/>
+        </p:spPr>
+        <p:txBody>
+          <a:bodyPr wrap="square" lIns="0" tIns="0" rIns="0" bIns="0" rtlCol="0" anchor="t">
+            <a:spAutoFit/>
+          </a:bodyPr>
+          <a:lstStyle/>
+          <a:p>
+            <a:pPr marL="0" indent="0" algn="l">
+              <a:lnSpc>
+                <a:spcPct val="112000"/>
+              </a:lnSpc>
+              <a:buNone/>
+            </a:pPr>
+            <a:r>
+              <a:rPr lang="en-US" sz="1000" b="1" dirty="0">
+                <a:solidFill>
+                  <a:srgbClr val="457B9D"/>
+                </a:solidFill>
+                <a:latin typeface="Space Grotesk" pitchFamily="34" charset="0"/>
+                <a:ea typeface="Space Grotesk" pitchFamily="34" charset="-122"/>
+                <a:cs typeface="Space Grotesk" pitchFamily="34" charset="-120"/>
+              </a:rPr>
+              <a:t>A .ai/ parent directory scopes AI access to a single directory tree and provides a consistent home for your ICM templates, shared resources, and all generated project instances.</a:t>
+            </a:r>
+            <a:endParaRPr lang="en-US" sz="1000" dirty="0"/>
+          </a:p>
+        </p:txBody>
+      </p:sp>
+      <p:sp>
+        <p:nvSpPr>
+          <p:cNvPr id="5" name="Text 2"/>
+          <p:cNvSpPr/>
+          <p:nvPr/>
+        </p:nvSpPr>
+        <p:spPr>
+          <a:xfrm>
+            <a:off x="571500" y="1390650"/>
+            <a:ext cx="3771900" cy="3466800"/>
+          </a:xfrm>
+          <a:prstGeom prst="rect">
+            <a:avLst/>
+          </a:prstGeom>
+          <a:noFill/>
+          <a:ln/>
+        </p:spPr>
+        <p:txBody>
+          <a:bodyPr wrap="square" lIns="0" tIns="0" rIns="0" bIns="0" rtlCol="0" anchor="t">
+            <a:spAutoFit/>
+          </a:bodyPr>
+          <a:lstStyle/>
+          <a:p>
+            <a:pPr marL="0" indent="0" algn="l">
+              <a:lnSpc>
+                <a:spcPct val="140000"/>
+              </a:lnSpc>
+              <a:buNone/>
+            </a:pPr>
+            <a:r>
+              <a:rPr lang="en-US" sz="850" b="1" dirty="0">
+                <a:solidFill>
+                  <a:srgbClr val="E63946"/>
+                </a:solidFill>
+                <a:latin typeface="Courier New" pitchFamily="49" charset="0"/>
+              </a:rPr>
+              <a:t>.ai/</a:t>
+            </a:r>
+            <a:endParaRPr lang="en-US" sz="850" dirty="0"/>
+          </a:p>
+          <a:p>
+            <a:pPr marL="0" indent="0" algn="l">
+              <a:lnSpc>
+                <a:spcPct val="140000"/>
+              </a:lnSpc>
+              <a:buNone/>
+            </a:pPr>
+            <a:r>
+              <a:rPr lang="en-US" sz="850" dirty="0">
+                <a:solidFill>
+                  <a:srgbClr val="333333"/>
+                </a:solidFill>
+                <a:latin typeface="Courier New" pitchFamily="49" charset="0"/>
+              </a:rPr>
+              <a:t>├── ICM/</a:t>
+            </a:r>
+            <a:endParaRPr lang="en-US" sz="850" dirty="0"/>
+          </a:p>
+          <a:p>
+            <a:pPr marL="0" indent="0" algn="l">
+              <a:lnSpc>
+                <a:spcPct val="140000"/>
+              </a:lnSpc>
+              <a:buNone/>
+            </a:pPr>
+            <a:r>
+              <a:rPr lang="en-US" sz="850" dirty="0">
+                <a:solidFill>
+                  <a:srgbClr val="333333"/>
+                </a:solidFill>
+                <a:latin typeface="Courier New" pitchFamily="49" charset="0"/>
+              </a:rPr>
+              <a:t>│   └── Templates/</a:t>
+            </a:r>
+            <a:endParaRPr lang="en-US" sz="850" dirty="0"/>
+          </a:p>
+          <a:p>
+            <a:pPr marL="0" indent="0" algn="l">
+              <a:lnSpc>
+                <a:spcPct val="140000"/>
+              </a:lnSpc>
+              <a:buNone/>
+            </a:pPr>
+            <a:r>
+              <a:rPr lang="en-US" sz="850" dirty="0">
+                <a:solidFill>
+                  <a:srgbClr val="555555"/>
+                </a:solidFill>
+                <a:latin typeface="Courier New" pitchFamily="49" charset="0"/>
+              </a:rPr>
+              <a:t>│       ├── README.md</a:t>
+            </a:r>
+            <a:endParaRPr lang="en-US" sz="850" dirty="0"/>
+          </a:p>
+          <a:p>
+            <a:pPr marL="0" indent="0" algn="l">
+              <a:lnSpc>
+                <a:spcPct val="140000"/>
+              </a:lnSpc>
+              <a:buNone/>
+            </a:pPr>
+            <a:r>
+              <a:rPr lang="en-US" sz="850" dirty="0">
+                <a:solidFill>
+                  <a:srgbClr val="555555"/>
+                </a:solidFill>
+                <a:latin typeface="Courier New" pitchFamily="49" charset="0"/>
+              </a:rPr>
+              <a:t>│       ├── generic-agent-oriented-ICM/</a:t>
+            </a:r>
+            <a:endParaRPr lang="en-US" sz="850" dirty="0"/>
+          </a:p>
+          <a:p>
+            <a:pPr marL="0" indent="0" algn="l">
+              <a:lnSpc>
+                <a:spcPct val="140000"/>
+              </a:lnSpc>
+              <a:buNone/>
+            </a:pPr>
+            <a:r>
+              <a:rPr lang="en-US" sz="850" dirty="0">
+                <a:solidFill>
+                  <a:srgbClr val="555555"/>
+                </a:solidFill>
+                <a:latin typeface="Courier New" pitchFamily="49" charset="0"/>
+              </a:rPr>
+              <a:t>│       └── systems-engineering-ICM/</a:t>
+            </a:r>
+            <a:endParaRPr lang="en-US" sz="850" dirty="0"/>
+          </a:p>
+          <a:p>
+            <a:pPr marL="0" indent="0" algn="l">
+              <a:lnSpc>
+                <a:spcPct val="140000"/>
+              </a:lnSpc>
+              <a:buNone/>
+            </a:pPr>
+            <a:r>
+              <a:rPr lang="en-US" sz="850" b="1" dirty="0">
+                <a:solidFill>
+                  <a:srgbClr val="457B9D"/>
+                </a:solidFill>
+                <a:latin typeface="Courier New" pitchFamily="49" charset="0"/>
+              </a:rPr>
+              <a:t>├── skills/</a:t>
+            </a:r>
+            <a:endParaRPr lang="en-US" sz="850" dirty="0"/>
+          </a:p>
+          <a:p>
+            <a:pPr marL="0" indent="0" algn="l">
+              <a:lnSpc>
+                <a:spcPct val="140000"/>
+              </a:lnSpc>
+              <a:buNone/>
+            </a:pPr>
+            <a:r>
+              <a:rPr lang="en-US" sz="850" b="1" dirty="0">
+                <a:solidFill>
+                  <a:srgbClr val="457B9D"/>
+                </a:solidFill>
+                <a:latin typeface="Courier New" pitchFamily="49" charset="0"/>
+              </a:rPr>
+              <a:t>├── memory/</a:t>
+            </a:r>
+            <a:endParaRPr lang="en-US" sz="850" dirty="0"/>
+          </a:p>
+          <a:p>
+            <a:pPr marL="0" indent="0" algn="l">
+              <a:lnSpc>
+                <a:spcPct val="140000"/>
+              </a:lnSpc>
+              <a:buNone/>
+            </a:pPr>
+            <a:r>
+              <a:rPr lang="en-US" sz="850" b="1" dirty="0">
+                <a:solidFill>
+                  <a:srgbClr val="457B9D"/>
+                </a:solidFill>
+                <a:latin typeface="Courier New" pitchFamily="49" charset="0"/>
+              </a:rPr>
+              <a:t>├── tools/</a:t>
+            </a:r>
+            <a:endParaRPr lang="en-US" sz="850" dirty="0"/>
+          </a:p>
+          <a:p>
+            <a:pPr marL="0" indent="0" algn="l">
+              <a:lnSpc>
+                <a:spcPct val="140000"/>
+              </a:lnSpc>
+              <a:buNone/>
+            </a:pPr>
+            <a:r>
+              <a:rPr lang="en-US" sz="850" dirty="0">
+                <a:solidFill>
+                  <a:srgbClr val="333333"/>
+                </a:solidFill>
+                <a:latin typeface="Courier New" pitchFamily="49" charset="0"/>
+              </a:rPr>
+              <a:t>├── my-first-project/</a:t>
+            </a:r>
+            <a:endParaRPr lang="en-US" sz="850" dirty="0"/>
+          </a:p>
+          <a:p>
+            <a:pPr marL="0" indent="0" algn="l">
+              <a:lnSpc>
+                <a:spcPct val="140000"/>
+              </a:lnSpc>
+              <a:buNone/>
+            </a:pPr>
+            <a:r>
+              <a:rPr lang="en-US" sz="850" dirty="0">
+                <a:solidFill>
+                  <a:srgbClr val="333333"/>
+                </a:solidFill>
+                <a:latin typeface="Courier New" pitchFamily="49" charset="0"/>
+              </a:rPr>
+              <a:t>└── my-second-project/</a:t>
+            </a:r>
+            <a:endParaRPr lang="en-US" sz="850" dirty="0"/>
+          </a:p>
+        </p:txBody>
+      </p:sp>
+      <p:sp>
+        <p:nvSpPr>
+          <p:cNvPr id="6" name="Text 3"/>
+          <p:cNvSpPr/>
+          <p:nvPr/>
+        </p:nvSpPr>
+        <p:spPr>
+          <a:xfrm>
+            <a:off x="4800375" y="1390650"/>
+            <a:ext cx="3914625" cy="742950"/>
+          </a:xfrm>
+          <a:prstGeom prst="rect">
+            <a:avLst/>
+          </a:prstGeom>
+          <a:noFill/>
+          <a:ln/>
+        </p:spPr>
+        <p:txBody>
+          <a:bodyPr wrap="square" lIns="0" tIns="0" rIns="0" bIns="0" rtlCol="0" anchor="t">
+            <a:spAutoFit/>
+          </a:bodyPr>
+          <a:lstStyle/>
+          <a:p>
+            <a:pPr marL="0" indent="0" algn="l">
+              <a:lnSpc>
+                <a:spcPct val="115000"/>
+              </a:lnSpc>
+              <a:buNone/>
+            </a:pPr>
+            <a:r>
+              <a:rPr lang="en-US" sz="900" b="1" dirty="0">
+                <a:solidFill>
+                  <a:srgbClr val="E63946"/>
+                </a:solidFill>
+                <a:latin typeface="Space Grotesk" pitchFamily="34" charset="0"/>
+                <a:ea typeface="Space Grotesk" pitchFamily="34" charset="-122"/>
+                <a:cs typeface="Space Grotesk" pitchFamily="34" charset="-120"/>
+              </a:rPr>
+              <a:t>.ai/</a:t>
+            </a:r>
+            <a:endParaRPr lang="en-US" sz="900" dirty="0"/>
+          </a:p>
+          <a:p>
+            <a:pPr marL="0" indent="0" algn="l">
+              <a:lnSpc>
+                <a:spcPct val="115000"/>
+              </a:lnSpc>
+              <a:buNone/>
+            </a:pPr>
+            <a:r>
+              <a:rPr lang="en-US" sz="850" dirty="0">
+                <a:solidFill>
+                  <a:srgbClr val="333333"/>
+                </a:solidFill>
+                <a:latin typeface="Space Grotesk" pitchFamily="34" charset="0"/>
+                <a:ea typeface="Space Grotesk" pitchFamily="34" charset="-122"/>
+                <a:cs typeface="Space Grotesk" pitchFamily="34" charset="-120"/>
+              </a:rPr>
+              <a:t>Scope AI access to this directory tree. The name signals where AI-assisted work lives to both humans and tools.</a:t>
+            </a:r>
+            <a:endParaRPr lang="en-US" sz="850" dirty="0"/>
+          </a:p>
+        </p:txBody>
+      </p:sp>
+      <p:sp>
+        <p:nvSpPr>
+          <p:cNvPr id="7" name="Text 4"/>
+          <p:cNvSpPr/>
+          <p:nvPr/>
+        </p:nvSpPr>
+        <p:spPr>
+          <a:xfrm>
+            <a:off x="4800375" y="2219850"/>
+            <a:ext cx="3914625" cy="628650"/>
+          </a:xfrm>
+          <a:prstGeom prst="rect">
+            <a:avLst/>
+          </a:prstGeom>
+          <a:noFill/>
+          <a:ln/>
+        </p:spPr>
+        <p:txBody>
+          <a:bodyPr wrap="square" lIns="0" tIns="0" rIns="0" bIns="0" rtlCol="0" anchor="t">
+            <a:spAutoFit/>
+          </a:bodyPr>
+          <a:lstStyle/>
+          <a:p>
+            <a:pPr marL="0" indent="0" algn="l">
+              <a:lnSpc>
+                <a:spcPct val="115000"/>
+              </a:lnSpc>
+              <a:buNone/>
+            </a:pPr>
+            <a:r>
+              <a:rPr lang="en-US" sz="900" b="1" dirty="0">
+                <a:solidFill>
+                  <a:srgbClr val="111111"/>
+                </a:solidFill>
+                <a:latin typeface="Space Grotesk" pitchFamily="34" charset="0"/>
+                <a:ea typeface="Space Grotesk" pitchFamily="34" charset="-122"/>
+                <a:cs typeface="Space Grotesk" pitchFamily="34" charset="-120"/>
+              </a:rPr>
+              <a:t>ICM/</a:t>
+            </a:r>
+            <a:endParaRPr lang="en-US" sz="900" dirty="0"/>
+          </a:p>
+          <a:p>
+            <a:pPr marL="0" indent="0" algn="l">
+              <a:lnSpc>
+                <a:spcPct val="115000"/>
+              </a:lnSpc>
+              <a:buNone/>
+            </a:pPr>
+            <a:r>
+              <a:rPr lang="en-US" sz="850" dirty="0">
+                <a:solidFill>
+                  <a:srgbClr val="333333"/>
+                </a:solidFill>
+                <a:latin typeface="Space Grotesk" pitchFamily="34" charset="0"/>
+                <a:ea typeface="Space Grotesk" pitchFamily="34" charset="-122"/>
+                <a:cs typeface="Space Grotesk" pitchFamily="34" charset="-120"/>
+              </a:rPr>
+              <a:t>This templates library. Clone it once and reuse it across all your projects.</a:t>
+            </a:r>
+            <a:endParaRPr lang="en-US" sz="850" dirty="0"/>
+          </a:p>
+        </p:txBody>
+      </p:sp>
+      <p:sp>
+        <p:nvSpPr>
+          <p:cNvPr id="8" name="Text 5"/>
+          <p:cNvSpPr/>
+          <p:nvPr/>
+        </p:nvSpPr>
+        <p:spPr>
+          <a:xfrm>
+            <a:off x="4800375" y="2934525"/>
+            <a:ext cx="3914625" cy="742950"/>
+          </a:xfrm>
+          <a:prstGeom prst="rect">
+            <a:avLst/>
+          </a:prstGeom>
+          <a:noFill/>
+          <a:ln/>
+        </p:spPr>
+        <p:txBody>
+          <a:bodyPr wrap="square" lIns="0" tIns="0" rIns="0" bIns="0" rtlCol="0" anchor="t">
+            <a:spAutoFit/>
+          </a:bodyPr>
+          <a:lstStyle/>
+          <a:p>
+            <a:pPr marL="0" indent="0" algn="l">
+              <a:lnSpc>
+                <a:spcPct val="115000"/>
+              </a:lnSpc>
+              <a:buNone/>
+            </a:pPr>
+            <a:r>
+              <a:rPr lang="en-US" sz="900" b="1" dirty="0">
+                <a:solidFill>
+                  <a:srgbClr val="457B9D"/>
+                </a:solidFill>
+                <a:latin typeface="Space Grotesk" pitchFamily="34" charset="0"/>
+                <a:ea typeface="Space Grotesk" pitchFamily="34" charset="-122"/>
+                <a:cs typeface="Space Grotesk" pitchFamily="34" charset="-120"/>
+              </a:rPr>
+              <a:t>skills/ &amp; memory/ &amp; tools/</a:t>
+            </a:r>
+            <a:endParaRPr lang="en-US" sz="900" dirty="0"/>
+          </a:p>
+          <a:p>
+            <a:pPr marL="0" indent="0" algn="l">
+              <a:lnSpc>
+                <a:spcPct val="115000"/>
+              </a:lnSpc>
+              <a:buNone/>
+            </a:pPr>
+            <a:r>
+              <a:rPr lang="en-US" sz="850" dirty="0">
+                <a:solidFill>
+                  <a:srgbClr val="333333"/>
+                </a:solidFill>
+                <a:latin typeface="Space Grotesk" pitchFamily="34" charset="0"/>
+                <a:ea typeface="Space Grotesk" pitchFamily="34" charset="-122"/>
+                <a:cs typeface="Space Grotesk" pitchFamily="34" charset="-120"/>
+              </a:rPr>
+              <a:t>Shared resources not tied to any single project: shared prompts, persistent cross-project context, and reusable scripts.</a:t>
+            </a:r>
+            <a:endParaRPr lang="en-US" sz="850" dirty="0"/>
+          </a:p>
+        </p:txBody>
+      </p:sp>
+      <p:sp>
+        <p:nvSpPr>
+          <p:cNvPr id="9" name="Text 6"/>
+          <p:cNvSpPr/>
+          <p:nvPr/>
+        </p:nvSpPr>
+        <p:spPr>
+          <a:xfrm>
+            <a:off x="4800375" y="3763725"/>
+            <a:ext cx="3914625" cy="742950"/>
+          </a:xfrm>
+          <a:prstGeom prst="rect">
+            <a:avLst/>
+          </a:prstGeom>
+          <a:noFill/>
+          <a:ln/>
+        </p:spPr>
+        <p:txBody>
+          <a:bodyPr wrap="square" lIns="0" tIns="0" rIns="0" bIns="0" rtlCol="0" anchor="t">
+            <a:spAutoFit/>
+          </a:bodyPr>
+          <a:lstStyle/>
+          <a:p>
+            <a:pPr marL="0" indent="0" algn="l">
+              <a:lnSpc>
+                <a:spcPct val="115000"/>
+              </a:lnSpc>
+              <a:buNone/>
+            </a:pPr>
+            <a:r>
+              <a:rPr lang="en-US" sz="900" b="1" dirty="0">
+                <a:solidFill>
+                  <a:srgbClr val="111111"/>
+                </a:solidFill>
+                <a:latin typeface="Space Grotesk" pitchFamily="34" charset="0"/>
+                <a:ea typeface="Space Grotesk" pitchFamily="34" charset="-122"/>
+                <a:cs typeface="Space Grotesk" pitchFamily="34" charset="-120"/>
+              </a:rPr>
+              <a:t>Project folders</a:t>
+            </a:r>
+            <a:endParaRPr lang="en-US" sz="900" dirty="0"/>
+          </a:p>
+          <a:p>
+            <a:pPr marL="0" indent="0" algn="l">
+              <a:lnSpc>
+                <a:spcPct val="115000"/>
+              </a:lnSpc>
+              <a:buNone/>
+            </a:pPr>
+            <a:r>
+              <a:rPr lang="en-US" sz="850" dirty="0">
+                <a:solidFill>
+                  <a:srgbClr val="333333"/>
+                </a:solidFill>
+                <a:latin typeface="Space Grotesk" pitchFamily="34" charset="0"/>
+                <a:ea typeface="Space Grotesk" pitchFamily="34" charset="-122"/>
+                <a:cs typeface="Space Grotesk" pitchFamily="34" charset="-120"/>
+              </a:rPr>
+              <a:t>Generated ICM instances live here as their own git repositories, sibling to ICM/ — not inside it.</a:t>
+            </a:r>
+            <a:endParaRPr lang="en-US" sz="850" dirty="0"/>
           </a:p>
         </p:txBody>
       </p:sp>
@@ -5080,7 +5772,7 @@
                 <a:ea typeface="Space Grotesk" pitchFamily="34" charset="-122"/>
                 <a:cs typeface="Space Grotesk" pitchFamily="34" charset="-120"/>
               </a:rPr>
-              <a:t>The folder structure itself </a:t>
+              <a:t xml:space="preserve">The folder structure itself </a:t>
             </a:r>
             <a:r>
               <a:rPr lang="en-US" sz="850" i="1" dirty="0">
@@ -5102,7 +5794,7 @@
                 <a:ea typeface="Space Grotesk" pitchFamily="34" charset="-122"/>
                 <a:cs typeface="Space Grotesk" pitchFamily="34" charset="-120"/>
               </a:rPr>
-              <a:t> the workflow engine: folder names, file names, and file contents collectively define what the agent should do and where.</a:t>
+              <a:t xml:space="preserve"> the workflow engine: folder names, file names, and file contents collectively define what the agent should do and where.</a:t>
             </a:r>
             <a:endParaRPr lang="en-US" sz="850" dirty="0"/>
           </a:p>
@@ -9359,7 +10051,7 @@
                 <a:ea typeface="Space Grotesk" pitchFamily="34" charset="-122"/>
                 <a:cs typeface="Space Grotesk" pitchFamily="34" charset="-120"/>
               </a:rPr>
-              <a:t>Choose </a:t>
+              <a:t xml:space="preserve">Choose </a:t>
             </a:r>
             <a:r>
               <a:rPr lang="en-US" sz="800" b="1" dirty="0">
@@ -9381,7 +10073,7 @@
                 <a:ea typeface="Space Grotesk" pitchFamily="34" charset="-122"/>
                 <a:cs typeface="Space Grotesk" pitchFamily="34" charset="-120"/>
               </a:rPr>
-              <a:t> for general projects or </a:t>
+              <a:t xml:space="preserve"> for general projects or </a:t>
             </a:r>
             <a:r>
               <a:rPr lang="en-US" sz="800" b="1" dirty="0">
@@ -9403,7 +10095,7 @@
                 <a:ea typeface="Space Grotesk" pitchFamily="34" charset="-122"/>
                 <a:cs typeface="Space Grotesk" pitchFamily="34" charset="-120"/>
               </a:rPr>
-              <a:t> for engineering-intensive work.</a:t>
+              <a:t xml:space="preserve"> for engineering-intensive work.</a:t>
             </a:r>
             <a:endParaRPr lang="en-US" sz="850" dirty="0"/>
           </a:p>

</xml_diff>

<commit_message>
Update PPTX/PDF to match revised creation flow and advanced options
- Slide 8: delivery is now environment-dependent (project created directly
  under .ai/ by local agents; ZIP only in chat environments) and the AI
  interview is one question at a time with options
- Slide 9: folder tree gains advanced-options/ (DIDs) under Templates/
- Slide 13: Looking Ahead notes the advanced options overlay and DoD DID
  library for formal contract deliverables
- PDF regenerated from the updated PPTX

Co-Authored-By: Claude Fable 5 <noreply@anthropic.com>
</commit_message>
<xml_diff>
--- a/Interpretable_Context_Methodology_(ICM).pptx
+++ b/Interpretable_Context_Methodology_(ICM).pptx
@@ -4001,7 +4001,7 @@
                 <a:ea typeface="Space Grotesk" pitchFamily="34" charset="-122"/>
                 <a:cs typeface="Space Grotesk" pitchFamily="34" charset="-120"/>
               </a:rPr>
-              <a:t>Additional ICM templates will be added to the library over time.</a:t>
+              <a:t>Advanced options add stage-gated pipelines and a DoD DID library for formal contract deliverables.</a:t>
             </a:r>
             <a:endParaRPr lang="en-US" sz="950" dirty="0"/>
           </a:p>
@@ -4587,7 +4587,25 @@
                 </a:solidFill>
                 <a:latin typeface="Courier New" pitchFamily="49" charset="0"/>
               </a:rPr>
-              <a:t>│       └── systems-engineering-ICM/</a:t>
+              <a:t>│       ├── systems-engineering-ICM/</a:t>
+            </a:r>
+            <a:endParaRPr lang="en-US" sz="850" dirty="0"/>
+          </a:p>
+          <a:p>
+            <a:pPr marL="0" indent="0" algn="l">
+              <a:lnSpc>
+                <a:spcPct val="140000"/>
+              </a:lnSpc>
+              <a:buNone/>
+            </a:pPr>
+            <a:r>
+              <a:rPr lang="en-US" sz="850" dirty="0">
+                <a:solidFill>
+                  <a:srgbClr val="555555"/>
+                </a:solidFill>
+                <a:latin typeface="Courier New" pitchFamily="49" charset="0"/>
+              </a:rPr>
+              <a:t>│       └── advanced-options/  (DIDs)</a:t>
             </a:r>
             <a:endParaRPr lang="en-US" sz="850" dirty="0"/>
           </a:p>
@@ -10347,7 +10365,7 @@
                 <a:ea typeface="Space Grotesk" pitchFamily="34" charset="-122"/>
                 <a:cs typeface="Space Grotesk" pitchFamily="34" charset="-120"/>
               </a:rPr>
-              <a:t>The AI gathers: project name, purpose, domain, technical stack, workflow stages, organizational structure, documentation requirements, and compliance constraints.</a:t>
+              <a:t>The AI asks one question at a time, presenting options, to gather: project name, purpose, domain, technical stack, workflow stages, organizational structure, documentation requirements, and compliance constraints.</a:t>
             </a:r>
             <a:endParaRPr lang="en-US" sz="850" dirty="0"/>
           </a:p>
@@ -10599,7 +10617,7 @@
                 <a:ea typeface="Space Grotesk" pitchFamily="34" charset="-122"/>
                 <a:cs typeface="Space Grotesk" pitchFamily="34" charset="-120"/>
               </a:rPr>
-              <a:t>The AI packages the result as a downloadable ZIP archive. The human initializes a git repository for version control to maintain organizational memory.</a:t>
+              <a:t>A local AI agent creates the project directly as a sibling folder under .ai/ (ZIP archive only in chat environments). The human initializes a git repository for version control to maintain organizational memory.</a:t>
             </a:r>
             <a:endParaRPr lang="en-US" sz="850" dirty="0"/>
           </a:p>

</xml_diff>

<commit_message>
Deck: show the .gitignore-before-first-commit sequence on Getting Started and Organizational Memory slides
Step 5 rebuilt as one text item (was four positioned boxes that overlapped
in the rendered PDF); code block extended with the review, git status and
reason lines. PDF regenerated.

Co-Authored-By: Claude Fable 5 <noreply@anthropic.com>
</commit_message>
<xml_diff>
--- a/Interpretable_Context_Methodology_(ICM).pptx
+++ b/Interpretable_Context_Methodology_(ICM).pptx
@@ -2378,7 +2378,7 @@
         <p:spPr>
           <a:xfrm>
             <a:off x="5657850" y="3731605"/>
-            <a:ext cx="2914650" cy="1017203"/>
+            <a:ext cx="2914650" cy="1200000"/>
           </a:xfrm>
           <a:prstGeom prst="rect">
             <a:avLst/>
@@ -2405,7 +2405,7 @@
         <p:spPr>
           <a:xfrm>
             <a:off x="5657850" y="3731605"/>
-            <a:ext cx="28575" cy="1017203"/>
+            <a:ext cx="28575" cy="1200000"/>
           </a:xfrm>
           <a:prstGeom prst="rect">
             <a:avLst/>
@@ -2432,16 +2432,16 @@
         <p:spPr>
           <a:xfrm>
             <a:off x="5657850" y="3731605"/>
-            <a:ext cx="2914650" cy="1017203"/>
-          </a:xfrm>
-          <a:prstGeom prst="rect">
-            <a:avLst/>
-          </a:prstGeom>
-          <a:noFill/>
-          <a:ln/>
-        </p:spPr>
-        <p:txBody>
-          <a:bodyPr wrap="square" lIns="170053" tIns="170053" rIns="170053" bIns="170053" rtlCol="0" anchor="t">
+            <a:ext cx="2914650" cy="1200000"/>
+          </a:xfrm>
+          <a:prstGeom prst="rect">
+            <a:avLst/>
+          </a:prstGeom>
+          <a:noFill/>
+          <a:ln/>
+        </p:spPr>
+        <p:txBody>
+          <a:bodyPr wrap="square" lIns="170053" tIns="120000" rIns="170053" bIns="120000" rtlCol="0" anchor="t">
             <a:spAutoFit/>
           </a:bodyPr>
           <a:lstStyle/>
@@ -2462,8 +2462,11 @@
                 <a:cs typeface="monospace" pitchFamily="34" charset="-120"/>
               </a:rPr>
               <a:t>git init
+# review .gitignore first — a file
+# committed once stays in history
+git status
 git add .
-git commit -m "Initial ICM project instance"</a:t>
+git commit -m "Initial ICM instance"</a:t>
             </a:r>
             <a:endParaRPr lang="en-US" sz="850" dirty="0"/>
           </a:p>
@@ -3688,23 +3691,23 @@
       </p:sp>
       <p:sp>
         <p:nvSpPr>
-          <p:cNvPr id="10" name="Text 7"/>
-          <p:cNvSpPr/>
-          <p:nvPr/>
-        </p:nvSpPr>
-        <p:spPr>
-          <a:xfrm>
-            <a:off x="964406" y="4027289"/>
-            <a:ext cx="1484114" cy="164306"/>
-          </a:xfrm>
-          <a:prstGeom prst="rect">
-            <a:avLst/>
-          </a:prstGeom>
-          <a:noFill/>
-          <a:ln/>
-        </p:spPr>
-        <p:txBody>
-          <a:bodyPr wrap="none" lIns="0" tIns="0" rIns="0" bIns="0" rtlCol="0" anchor="t">
+          <p:cNvPr id="14" name="Text 7"/>
+          <p:cNvSpPr/>
+          <p:nvPr/>
+        </p:nvSpPr>
+        <p:spPr>
+          <a:xfrm>
+            <a:off x="892969" y="4009448"/>
+            <a:ext cx="3679031" cy="440000"/>
+          </a:xfrm>
+          <a:prstGeom prst="rect">
+            <a:avLst/>
+          </a:prstGeom>
+          <a:noFill/>
+          <a:ln/>
+        </p:spPr>
+        <p:txBody>
+          <a:bodyPr wrap="square" lIns="85090" tIns="0" rIns="0" bIns="0" rtlCol="0" anchor="t">
             <a:spAutoFit/>
           </a:bodyPr>
           <a:lstStyle/>
@@ -3728,151 +3731,30 @@
               </a:rPr>
               <a:t>Initialize version control</a:t>
             </a:r>
+            <a:r>
+              <a:rPr lang="en-US" sz="950" dirty="0">
+                <a:solidFill>
+                  <a:srgbClr val="333333"/>
+                </a:solidFill>
+                <a:latin typeface="Space Grotesk" pitchFamily="34" charset="0"/>
+                <a:ea typeface="Space Grotesk" pitchFamily="34" charset="-122"/>
+                <a:cs typeface="Space Grotesk" pitchFamily="34" charset="-120"/>
+              </a:rPr>
+              <a:t xml:space="preserve"> — run git init, review the generated .gitignore against your stack, check git status, then make the first commit.</a:t>
+            </a:r>
             <a:endParaRPr lang="en-US" sz="900" dirty="0"/>
           </a:p>
         </p:txBody>
       </p:sp>
       <p:sp>
         <p:nvSpPr>
-          <p:cNvPr id="11" name="Text 8"/>
-          <p:cNvSpPr/>
-          <p:nvPr/>
-        </p:nvSpPr>
-        <p:spPr>
-          <a:xfrm>
-            <a:off x="2448520" y="4027289"/>
-            <a:ext cx="417909" cy="164306"/>
-          </a:xfrm>
-          <a:prstGeom prst="rect">
-            <a:avLst/>
-          </a:prstGeom>
-          <a:noFill/>
-          <a:ln/>
-        </p:spPr>
-        <p:txBody>
-          <a:bodyPr wrap="none" lIns="0" tIns="0" rIns="0" bIns="0" rtlCol="0" anchor="t">
-            <a:spAutoFit/>
-          </a:bodyPr>
-          <a:lstStyle/>
-          <a:p>
-            <a:pPr marL="0" indent="0" algn="l">
-              <a:lnSpc>
-                <a:spcPct val="120000"/>
-              </a:lnSpc>
-              <a:buNone/>
-            </a:pPr>
-            <a:r>
-              <a:rPr lang="en-US" sz="950" dirty="0">
-                <a:solidFill>
-                  <a:srgbClr val="333333"/>
-                </a:solidFill>
-                <a:latin typeface="Space Grotesk" pitchFamily="34" charset="0"/>
-                <a:ea typeface="Space Grotesk" pitchFamily="34" charset="-122"/>
-                <a:cs typeface="Space Grotesk" pitchFamily="34" charset="-120"/>
-              </a:rPr>
-              <a:t>— run</a:t>
-            </a:r>
-            <a:endParaRPr lang="en-US" sz="950" dirty="0"/>
-          </a:p>
-        </p:txBody>
-      </p:sp>
-      <p:sp>
-        <p:nvSpPr>
-          <p:cNvPr id="12" name="Text 9"/>
-          <p:cNvSpPr/>
-          <p:nvPr/>
-        </p:nvSpPr>
-        <p:spPr>
-          <a:xfrm>
-            <a:off x="2795689" y="4032238"/>
-            <a:ext cx="617237" cy="175022"/>
-          </a:xfrm>
-          <a:prstGeom prst="rect">
-            <a:avLst/>
-          </a:prstGeom>
-          <a:noFill/>
-          <a:ln/>
-        </p:spPr>
-        <p:txBody>
-          <a:bodyPr wrap="none" lIns="0" tIns="0" rIns="0" bIns="0" rtlCol="0" anchor="t">
-            <a:spAutoFit/>
-          </a:bodyPr>
-          <a:lstStyle/>
-          <a:p>
-            <a:pPr marL="0" indent="0" algn="l">
-              <a:lnSpc>
-                <a:spcPct val="120000"/>
-              </a:lnSpc>
-              <a:buNone/>
-            </a:pPr>
-            <a:r>
-              <a:rPr lang="en-US" sz="950" dirty="0">
-                <a:solidFill>
-                  <a:srgbClr val="333333"/>
-                </a:solidFill>
-                <a:latin typeface="monospace" pitchFamily="34" charset="0"/>
-                <a:ea typeface="monospace" pitchFamily="34" charset="-122"/>
-                <a:cs typeface="monospace" pitchFamily="34" charset="-120"/>
-              </a:rPr>
-              <a:t>git init</a:t>
-            </a:r>
-            <a:endParaRPr lang="en-US" sz="950" dirty="0"/>
-          </a:p>
-        </p:txBody>
-      </p:sp>
-      <p:sp>
-        <p:nvSpPr>
-          <p:cNvPr id="13" name="Text 10"/>
-          <p:cNvSpPr/>
-          <p:nvPr/>
-        </p:nvSpPr>
-        <p:spPr>
-          <a:xfrm>
-            <a:off x="1096915" y="4200525"/>
-            <a:ext cx="3539030" cy="357188"/>
-          </a:xfrm>
-          <a:prstGeom prst="rect">
-            <a:avLst/>
-          </a:prstGeom>
-          <a:noFill/>
-          <a:ln/>
-        </p:spPr>
-        <p:txBody>
-          <a:bodyPr wrap="square" lIns="0" tIns="0" rIns="0" bIns="0" rtlCol="0" anchor="t">
-            <a:spAutoFit/>
-          </a:bodyPr>
-          <a:lstStyle/>
-          <a:p>
-            <a:pPr marL="0" indent="0" algn="l">
-              <a:lnSpc>
-                <a:spcPct val="120000"/>
-              </a:lnSpc>
-              <a:buNone/>
-            </a:pPr>
-            <a:r>
-              <a:rPr lang="en-US" sz="950" dirty="0">
-                <a:solidFill>
-                  <a:srgbClr val="333333"/>
-                </a:solidFill>
-                <a:latin typeface="Space Grotesk" pitchFamily="34" charset="0"/>
-                <a:ea typeface="Space Grotesk" pitchFamily="34" charset="-122"/>
-                <a:cs typeface="Space Grotesk" pitchFamily="34" charset="-120"/>
-              </a:rPr>
-              <a:t>and commit the initial structure.</a:t>
-            </a:r>
-            <a:endParaRPr lang="en-US" sz="950" dirty="0"/>
-          </a:p>
-        </p:txBody>
-      </p:sp>
-      <p:sp>
-        <p:nvSpPr>
           <p:cNvPr id="14" name="Text 11"/>
           <p:cNvSpPr/>
           <p:nvPr/>
         </p:nvSpPr>
         <p:spPr>
           <a:xfrm>
-            <a:off x="892969" y="4455914"/>
+            <a:off x="892969" y="4580000"/>
             <a:ext cx="3679031" cy="385763"/>
           </a:xfrm>
           <a:prstGeom prst="rect">

</xml_diff>

<commit_message>
Deck: DID library attributed to SE-Deliverables (slides 6, 12); slide 6 sys-eng column matches template
Co-Authored-By: Claude Fable 5 <noreply@anthropic.com>
</commit_message>
<xml_diff>
--- a/Interpretable_Context_Methodology_(ICM).pptx
+++ b/Interpretable_Context_Methodology_(ICM).pptx
@@ -3883,7 +3883,7 @@
                 <a:ea typeface="Space Grotesk" pitchFamily="34" charset="-122"/>
                 <a:cs typeface="Space Grotesk" pitchFamily="34" charset="-120"/>
               </a:rPr>
-              <a:t>Advanced options add stage-gated pipelines and a DoD DID library for formal contract deliverables.</a:t>
+              <a:t>Advanced options add stage-gated pipelines; formal deliverables come from the companion SE-Deliverables library.</a:t>
             </a:r>
             <a:endParaRPr lang="en-US" sz="950" dirty="0"/>
           </a:p>
@@ -7448,7 +7448,7 @@
                 <a:ea typeface="Space Grotesk" pitchFamily="34" charset="-122"/>
                 <a:cs typeface="Space Grotesk" pitchFamily="34" charset="-120"/>
               </a:rPr>
-              <a:t>The ICM template library includes two base templates, each designed for a different class of project, plus an advanced overlay adding stage-gated pipelines and a DoD DID library.</a:t>
+              <a:t>The ICM template library includes two base templates, each designed for a different class of project, plus an advanced overlay for stage-gated pipelines. Deliverables come from the companion SE-Deliverables library.</a:t>
             </a:r>
             <a:endParaRPr lang="en-US" sz="1000" dirty="0"/>
           </a:p>
@@ -7938,7 +7938,7 @@
         </p:nvSpPr>
         <p:spPr>
           <a:xfrm>
-            <a:off x="4929188" y="3479341"/>
+            <a:off x="4929188" y="3432886"/>
             <a:ext cx="3643313" cy="320018"/>
           </a:xfrm>
           <a:prstGeom prst="rect">
@@ -7988,13 +7988,69 @@
       </p:sp>
       <p:sp>
         <p:nvSpPr>
+          <p:cNvPr id="30" name="Text 22"/>
+          <p:cNvSpPr/>
+          <p:nvPr/>
+        </p:nvSpPr>
+        <p:spPr>
+          <a:xfrm>
+            <a:off x="4929188" y="3777886"/>
+            <a:ext cx="3643313" cy="320018"/>
+          </a:xfrm>
+          <a:prstGeom prst="rect">
+            <a:avLst/>
+          </a:prstGeom>
+          <a:noFill/>
+          <a:ln/>
+        </p:spPr>
+        <p:txBody>
+          <a:bodyPr wrap="square" lIns="127508" tIns="0" rIns="0" bIns="0" rtlCol="0" anchor="t">
+            <a:spAutoFit/>
+          </a:bodyPr>
+          <a:lstStyle/>
+          <a:p>
+            <a:pPr marL="0" indent="0" algn="l">
+              <a:lnSpc>
+                <a:spcPct val="112000"/>
+              </a:lnSpc>
+              <a:buNone/>
+            </a:pPr>
+            <a:r>
+              <a:rPr lang="en-US" sz="800" b="1" dirty="0">
+                <a:solidFill>
+                  <a:srgbClr val="111111"/>
+                </a:solidFill>
+                <a:latin typeface="Space Grotesk" pitchFamily="34" charset="0"/>
+                <a:ea typeface="Space Grotesk" pitchFamily="34" charset="-122"/>
+                <a:cs typeface="Space Grotesk" pitchFamily="34" charset="-120"/>
+              </a:rPr>
+              <a:t>requirements/</a:t>
+            </a:r>
+            <a:r>
+              <a:rPr lang="en-US" sz="850" dirty="0">
+                <a:solidFill>
+                  <a:srgbClr val="333333"/>
+                </a:solidFill>
+                <a:latin typeface="Space Grotesk" pitchFamily="34" charset="0"/>
+                <a:ea typeface="Space Grotesk" pitchFamily="34" charset="-122"/>
+                <a:cs typeface="Space Grotesk" pitchFamily="34" charset="-120"/>
+              </a:rPr>
+              <a:t>
+Capture, baseline, trace</a:t>
+            </a:r>
+            <a:endParaRPr lang="en-US" sz="800" dirty="0"/>
+          </a:p>
+        </p:txBody>
+      </p:sp>
+      <p:sp>
+        <p:nvSpPr>
           <p:cNvPr id="16" name="Text 13"/>
           <p:cNvSpPr/>
           <p:nvPr/>
         </p:nvSpPr>
         <p:spPr>
           <a:xfrm>
-            <a:off x="4929188" y="3870796"/>
+            <a:off x="4929188" y="4122886"/>
             <a:ext cx="3643313" cy="320018"/>
           </a:xfrm>
           <a:prstGeom prst="rect">
@@ -8050,7 +8106,7 @@
         </p:nvSpPr>
         <p:spPr>
           <a:xfrm>
-            <a:off x="4929188" y="4333689"/>
+            <a:off x="4929188" y="4530000"/>
             <a:ext cx="3643313" cy="146447"/>
           </a:xfrm>
           <a:prstGeom prst="rect">
@@ -8091,7 +8147,7 @@
         </p:nvSpPr>
         <p:spPr>
           <a:xfrm>
-            <a:off x="4929188" y="4551573"/>
+            <a:off x="4929188" y="4740000"/>
             <a:ext cx="3643313" cy="300038"/>
           </a:xfrm>
           <a:prstGeom prst="rect">
@@ -8121,7 +8177,7 @@
                 <a:ea typeface="Space Grotesk" pitchFamily="34" charset="-122"/>
                 <a:cs typeface="Space Grotesk" pitchFamily="34" charset="-120"/>
               </a:rPr>
-              <a:t>requirements/, standards/, templates/, state/, decisions/, risk-management/, compliance/, metrics/, governance/, verification-validation/</a:t>
+              <a:t>standards/, templates/, state/, decisions/, risk-management/, compliance/, configuration-management/, metrics/, governance/, verification-validation/</a:t>
             </a:r>
             <a:endParaRPr lang="en-US" sz="700" dirty="0"/>
           </a:p>

</xml_diff>